<commit_message>
Final: demo video link and presentation
</commit_message>
<xml_diff>
--- a/docs/SmartTutor-presentation.pptx
+++ b/docs/SmartTutor-presentation.pptx
@@ -5,17 +5,18 @@
     <p:sldMasterId id="2147483648" r:id="rId1"/>
   </p:sldMasterIdLst>
   <p:notesMasterIdLst>
-    <p:notesMasterId r:id="rId10"/>
+    <p:notesMasterId r:id="rId11"/>
   </p:notesMasterIdLst>
   <p:sldIdLst>
     <p:sldId id="256" r:id="rId2"/>
     <p:sldId id="257" r:id="rId3"/>
     <p:sldId id="258" r:id="rId4"/>
-    <p:sldId id="259" r:id="rId5"/>
-    <p:sldId id="260" r:id="rId6"/>
+    <p:sldId id="260" r:id="rId5"/>
+    <p:sldId id="259" r:id="rId6"/>
     <p:sldId id="261" r:id="rId7"/>
     <p:sldId id="263" r:id="rId8"/>
     <p:sldId id="264" r:id="rId9"/>
+    <p:sldId id="265" r:id="rId10"/>
   </p:sldIdLst>
   <p:sldSz cx="9144000" cy="5143500" type="screen16x9"/>
   <p:notesSz cx="5143500" cy="9144000"/>
@@ -144,7 +145,7 @@
     </p:spTree>
     <p:extLst>
       <p:ext uri="{BB962C8B-B14F-4D97-AF65-F5344CB8AC3E}">
-        <p14:creationId xmlns:p14="http://schemas.microsoft.com/office/powerpoint/2010/main" val="4238809635"/>
+        <p14:creationId xmlns:p14="http://schemas.microsoft.com/office/powerpoint/2010/main" val="4129499797"/>
       </p:ext>
     </p:extLst>
   </p:cSld>
@@ -290,7 +291,7 @@
           <a:p>
             <a:r>
               <a:rPr lang="en-US" dirty="0"/>
-              <a:t>Good morning. Thank you for your time today. I am [name], applying for [position]. My solution is SmartTutor: a mobile app that turns any document, such as a policy, a process or an onboarding guide, into a complete training course: a narrated video under five minutes and a one-page infographic. It takes a few minutes and costs about six cents per course. In about eight minutes I will cover four parts: what the app is, a live demo, how the system works, and finally the current limitations and the roadmap.</a:t>
+              <a:t>Good morning. Thank you for your time today. I am [name], applying for [position]. My solution is SmartTutor: a mobile app that turns any document, such as a policy, a process or an onboarding guide, into a complete training course: a narrated video under five minutes and a one-page infographic. It takes a few minutes and costs about six cents per course. In about eight minutes I will cover four parts: what the app is, a demo, how the system works, and finally the current limitations and the roadmap.</a:t>
             </a:r>
           </a:p>
         </p:txBody>
@@ -551,7 +552,7 @@
           <a:p>
             <a:r>
               <a:rPr lang="en-US" dirty="0"/>
-              <a:t>The pipeline has four main steps. One: Gemini reads the document and writes the whole course in a single structured call, so the video and the infographic always agree. Two: media is produced in parallel: narration, real footage from Pexels, and photos for the infographic. Three: the system measures the real length of the voice-over to guarantee the video stays under five minutes. Four: the infographic and the video are rendered by code, so every word is spelled correctly, including Vietnamese diacritics. Finally the app polls the status and downloads the results.</a:t>
+              <a:t>The system has four blocks: the mobile app, the application server, the video and infographic renderers, and external AI services. The app uploads the document; the server immediately returns a task id and works in the background while the app polls for progress, so an unstable mobile connection never loses the result. On security: the mobile app holds no API keys; every key lives only on the server.</a:t>
             </a:r>
           </a:p>
         </p:txBody>
@@ -638,7 +639,7 @@
           <a:p>
             <a:r>
               <a:rPr lang="en-US" dirty="0"/>
-              <a:t>The system has four blocks: the mobile app, the application server, the video and infographic renderers, and external AI services. The app uploads the document; the server immediately returns a task id and works in the background while the app polls for progress, so an unstable mobile connection never loses the result. On security: the mobile app holds no API keys; every key lives only on the server.</a:t>
+              <a:t>The pipeline has four main steps. One: Gemini reads the document and writes the whole course in a single structured call, so the video and the infographic always agree. Two: media is produced in parallel: narration, real footage from Pexels, and photos for the infographic. Three: the system measures the real length of the voice-over to guarantee the video stays under five minutes. Four: the infographic and the video are rendered by code, so every word is spelled correctly, including Vietnamese diacritics. Finally the app polls the status and downloads the results.</a:t>
             </a:r>
           </a:p>
         </p:txBody>
@@ -899,7 +900,7 @@
           <a:p>
             <a:r>
               <a:rPr lang="en-US" dirty="0"/>
-              <a:t>If I continue, I would prioritise three things. One: move to the cloud with a job queue and parallel rendering, so many users can generate at once in seconds. Two: let HR review and edit the script before rendering, to stay in control of the content. Three: scored quizzes and export to the company's LMS. I see SmartTutor as a training module in an HR platform: HR uploads processes and policies, the system builds the lessons, and tracks which employees completed them. Thank you for listening. I am happy to take your questions.</a:t>
+              <a:t>If I continue, I would prioritise three things. One: move to the cloud with a job queue and parallel rendering, so many users can generate at once in seconds. Two: let HR review and edit the script before rendering, to stay in control of the content. Three: scored quizzes and export to the company's LMS. I see SmartTutor as a training module in an HR platform: HR uploads processes and policies, the system builds the lessons, and tracks which employees completed them.</a:t>
             </a:r>
           </a:p>
         </p:txBody>
@@ -922,6 +923,93 @@
             <a:fld id="{F7021451-1387-4CA6-816F-3879F97B5CBC}" type="slidenum">
               <a:rPr lang="en-US"/>
               <a:t>8</a:t>
+            </a:fld>
+            <a:endParaRPr lang="en-US"/>
+          </a:p>
+        </p:txBody>
+      </p:sp>
+    </p:spTree>
+    <p:extLst>
+      <p:ext uri="{BB962C8B-B14F-4D97-AF65-F5344CB8AC3E}">
+        <p14:creationId xmlns:p14="http://schemas.microsoft.com/office/powerpoint/2010/main" val="1024086991"/>
+      </p:ext>
+    </p:extLst>
+  </p:cSld>
+  <p:clrMapOvr>
+    <a:masterClrMapping/>
+  </p:clrMapOvr>
+</p:notes>
+</file>
+
+<file path=ppt/notesSlides/notesSlide9.xml><?xml version="1.0" encoding="utf-8"?>
+<p:notes xmlns:a="http://schemas.openxmlformats.org/drawingml/2006/main" xmlns:r="http://schemas.openxmlformats.org/officeDocument/2006/relationships" xmlns:p="http://schemas.openxmlformats.org/presentationml/2006/main">
+  <p:cSld>
+    <p:spTree>
+      <p:nvGrpSpPr>
+        <p:cNvPr id="1" name=""/>
+        <p:cNvGrpSpPr/>
+        <p:nvPr/>
+      </p:nvGrpSpPr>
+      <p:grpSpPr>
+        <a:xfrm>
+          <a:off x="0" y="0"/>
+          <a:ext cx="0" cy="0"/>
+          <a:chOff x="0" y="0"/>
+          <a:chExt cx="0" cy="0"/>
+        </a:xfrm>
+      </p:grpSpPr>
+      <p:sp>
+        <p:nvSpPr>
+          <p:cNvPr id="2" name="Slide Image Placeholder 1"/>
+          <p:cNvSpPr>
+            <a:spLocks noGrp="1" noRot="1" noChangeAspect="1"/>
+          </p:cNvSpPr>
+          <p:nvPr>
+            <p:ph type="sldImg"/>
+          </p:nvPr>
+        </p:nvSpPr>
+        <p:spPr/>
+      </p:sp>
+      <p:sp>
+        <p:nvSpPr>
+          <p:cNvPr id="3" name="Notes Placeholder 2"/>
+          <p:cNvSpPr>
+            <a:spLocks noGrp="1"/>
+          </p:cNvSpPr>
+          <p:nvPr>
+            <p:ph type="body" idx="1"/>
+          </p:nvPr>
+        </p:nvSpPr>
+        <p:spPr/>
+        <p:txBody>
+          <a:bodyPr/>
+          <a:lstStyle/>
+          <a:p>
+            <a:r>
+              <a:rPr lang="en-US" dirty="0"/>
+              <a:t>Thank you for listening.</a:t>
+            </a:r>
+          </a:p>
+        </p:txBody>
+      </p:sp>
+      <p:sp>
+        <p:nvSpPr>
+          <p:cNvPr id="4" name="Slide Number Placeholder 3"/>
+          <p:cNvSpPr>
+            <a:spLocks noGrp="1"/>
+          </p:cNvSpPr>
+          <p:nvPr>
+            <p:ph type="sldNum" sz="quarter" idx="10"/>
+          </p:nvPr>
+        </p:nvSpPr>
+        <p:spPr/>
+        <p:txBody>
+          <a:bodyPr/>
+          <a:lstStyle/>
+          <a:p>
+            <a:fld id="{F7021451-1387-4CA6-816F-3879F97B5CBC}" type="slidenum">
+              <a:rPr lang="en-US"/>
+              <a:t>9</a:t>
             </a:fld>
             <a:endParaRPr lang="en-US"/>
           </a:p>
@@ -1285,8 +1373,8 @@
         </p:nvSpPr>
         <p:spPr>
           <a:xfrm>
-            <a:off x="548640" y="1234440"/>
-            <a:ext cx="4389120" cy="822960"/>
+            <a:off x="548640" y="1188720"/>
+            <a:ext cx="4389120" cy="868680"/>
           </a:xfrm>
           <a:prstGeom prst="rect">
             <a:avLst/>
@@ -1295,7 +1383,7 @@
           <a:ln/>
         </p:spPr>
         <p:txBody>
-          <a:bodyPr wrap="square" lIns="0" tIns="0" rIns="0" bIns="0" rtlCol="0" anchor="ctr"/>
+          <a:bodyPr wrap="square" lIns="0" tIns="0" rIns="0" bIns="0" rtlCol="0" anchor="t"/>
           <a:lstStyle/>
           <a:p>
             <a:pPr marL="0" indent="0">
@@ -1325,7 +1413,7 @@
         <p:spPr>
           <a:xfrm>
             <a:off x="548640" y="2057400"/>
-            <a:ext cx="4206240" cy="822960"/>
+            <a:ext cx="4114800" cy="822960"/>
           </a:xfrm>
           <a:prstGeom prst="rect">
             <a:avLst/>
@@ -1334,7 +1422,7 @@
           <a:ln/>
         </p:spPr>
         <p:txBody>
-          <a:bodyPr wrap="square" lIns="0" tIns="0" rIns="0" bIns="0" rtlCol="0" anchor="ctr"/>
+          <a:bodyPr wrap="square" lIns="0" tIns="0" rIns="0" bIns="0" rtlCol="0" anchor="t"/>
           <a:lstStyle/>
           <a:p>
             <a:pPr marL="0" indent="0">
@@ -1363,8 +1451,8 @@
         </p:nvSpPr>
         <p:spPr>
           <a:xfrm>
-            <a:off x="548640" y="2880360"/>
-            <a:ext cx="4023360" cy="731520"/>
+            <a:off x="548640" y="2926080"/>
+            <a:ext cx="3931920" cy="731520"/>
           </a:xfrm>
           <a:prstGeom prst="rect">
             <a:avLst/>
@@ -1373,7 +1461,7 @@
           <a:ln/>
         </p:spPr>
         <p:txBody>
-          <a:bodyPr wrap="square" lIns="0" tIns="0" rIns="0" bIns="0" rtlCol="0" anchor="ctr"/>
+          <a:bodyPr wrap="square" lIns="0" tIns="0" rIns="0" bIns="0" rtlCol="0" anchor="t"/>
           <a:lstStyle/>
           <a:p>
             <a:pPr marL="0" indent="0">
@@ -1412,7 +1500,7 @@
           <a:ln/>
         </p:spPr>
         <p:txBody>
-          <a:bodyPr wrap="square" lIns="0" tIns="0" rIns="0" bIns="0" rtlCol="0" anchor="ctr"/>
+          <a:bodyPr wrap="square" lIns="0" tIns="0" rIns="0" bIns="0" rtlCol="0" anchor="t"/>
           <a:lstStyle/>
           <a:p>
             <a:pPr marL="0" indent="0">
@@ -1427,7 +1515,7 @@
                 <a:ea typeface="Calibri" pitchFamily="34" charset="-122"/>
                 <a:cs typeface="Calibri" pitchFamily="34" charset="-120"/>
               </a:rPr>
-              <a:t>[Dinh Hoang Phuc]   ·  October 2026</a:t>
+              <a:t>Dinh Hoang Phuc   ·  October 2026</a:t>
             </a:r>
             <a:endParaRPr lang="en-US" sz="1200" dirty="0"/>
           </a:p>
@@ -1455,6 +1543,13 @@
           <a:prstGeom prst="rect">
             <a:avLst/>
           </a:prstGeom>
+          <a:effectLst>
+            <a:outerShdw blurRad="177800" dist="50800" dir="5400000" algn="bl" rotWithShape="0">
+              <a:srgbClr val="000000">
+                <a:alpha val="35000"/>
+              </a:srgbClr>
+            </a:outerShdw>
+          </a:effectLst>
         </p:spPr>
       </p:pic>
       <p:sp>
@@ -1465,8 +1560,8 @@
         </p:nvSpPr>
         <p:spPr>
           <a:xfrm>
-            <a:off x="4846320" y="3474720"/>
-            <a:ext cx="3840480" cy="320040"/>
+            <a:off x="4846320" y="3520440"/>
+            <a:ext cx="3840480" cy="274320"/>
           </a:xfrm>
           <a:prstGeom prst="rect">
             <a:avLst/>
@@ -1475,7 +1570,7 @@
           <a:ln/>
         </p:spPr>
         <p:txBody>
-          <a:bodyPr wrap="square" lIns="0" tIns="0" rIns="0" bIns="0" rtlCol="0" anchor="ctr"/>
+          <a:bodyPr wrap="square" lIns="0" tIns="0" rIns="0" bIns="0" rtlCol="0" anchor="t"/>
           <a:lstStyle/>
           <a:p>
             <a:pPr marL="0" indent="0">
@@ -1510,7 +1605,7 @@
     <p:bg>
       <p:bgPr>
         <a:solidFill>
-          <a:srgbClr val="FFFFFF"/>
+          <a:srgbClr val="F5F8FF"/>
         </a:solidFill>
         <a:effectLst/>
       </p:bgPr>
@@ -1586,7 +1681,7 @@
           <a:ln/>
         </p:spPr>
         <p:txBody>
-          <a:bodyPr wrap="square" lIns="0" tIns="0" rIns="0" bIns="0" rtlCol="0" anchor="ctr"/>
+          <a:bodyPr wrap="square" lIns="0" tIns="0" rIns="0" bIns="0" rtlCol="0" anchor="t"/>
           <a:lstStyle/>
           <a:p>
             <a:pPr marL="0" indent="0">
@@ -1615,37 +1710,258 @@
         </p:nvSpPr>
         <p:spPr>
           <a:xfrm>
-            <a:off x="457200" y="1554480"/>
-            <a:ext cx="2651760" cy="2103120"/>
+            <a:off x="457200" y="1508760"/>
+            <a:ext cx="2651760" cy="2240280"/>
           </a:xfrm>
           <a:prstGeom prst="roundRect">
             <a:avLst>
-              <a:gd name="adj" fmla="val 5217"/>
+              <a:gd name="adj" fmla="val 4898"/>
             </a:avLst>
           </a:prstGeom>
           <a:solidFill>
-            <a:srgbClr val="EAF1FF"/>
+            <a:srgbClr val="FFFFFF"/>
+          </a:solidFill>
+          <a:ln w="9525">
+            <a:solidFill>
+              <a:srgbClr val="DCE3F2"/>
+            </a:solidFill>
+            <a:prstDash val="solid"/>
+          </a:ln>
+          <a:effectLst>
+            <a:outerShdw blurRad="127000" dist="38100" dir="5400000" algn="bl" rotWithShape="0">
+              <a:srgbClr val="0F1B3D">
+                <a:alpha val="12000"/>
+              </a:srgbClr>
+            </a:outerShdw>
+          </a:effectLst>
+        </p:spPr>
+      </p:sp>
+      <p:sp>
+        <p:nvSpPr>
+          <p:cNvPr id="5" name="Shape 3"/>
+          <p:cNvSpPr/>
+          <p:nvPr/>
+        </p:nvSpPr>
+        <p:spPr>
+          <a:xfrm>
+            <a:off x="685800" y="1737360"/>
+            <a:ext cx="777240" cy="777240"/>
+          </a:xfrm>
+          <a:prstGeom prst="roundRect">
+            <a:avLst>
+              <a:gd name="adj" fmla="val 22000"/>
+            </a:avLst>
+          </a:prstGeom>
+          <a:solidFill>
+            <a:srgbClr val="FFFFFF"/>
           </a:solidFill>
           <a:ln w="12700">
             <a:solidFill>
-              <a:srgbClr val="EAF1FF"/>
+              <a:srgbClr val="FFFFFF"/>
             </a:solidFill>
             <a:prstDash val="solid"/>
           </a:ln>
-        </p:spPr>
-      </p:sp>
-      <p:sp>
-        <p:nvSpPr>
-          <p:cNvPr id="5" name="Shape 3"/>
+          <a:effectLst>
+            <a:outerShdw blurRad="127000" dist="38100" dir="5400000" algn="bl" rotWithShape="0">
+              <a:srgbClr val="0F1B3D">
+                <a:alpha val="12000"/>
+              </a:srgbClr>
+            </a:outerShdw>
+          </a:effectLst>
+        </p:spPr>
+      </p:sp>
+      <p:pic>
+        <p:nvPicPr>
+          <p:cNvPr id="6" name="Image 0" descr="C:\Users\Admin\AppData\Local\Temp\claude\d--SmartTutor\5ff2c210-ed39-47c1-9187-8611ef6ccd50\scratchpad\deck\emoji\doc.png"/>
+          <p:cNvPicPr>
+            <a:picLocks noChangeAspect="1"/>
+          </p:cNvPicPr>
+          <p:nvPr/>
+        </p:nvPicPr>
+        <p:blipFill>
+          <a:blip r:embed="rId3"/>
+          <a:stretch>
+            <a:fillRect/>
+          </a:stretch>
+        </p:blipFill>
+        <p:spPr>
+          <a:xfrm>
+            <a:off x="810158" y="1861718"/>
+            <a:ext cx="528523" cy="528523"/>
+          </a:xfrm>
+          <a:prstGeom prst="rect">
+            <a:avLst/>
+          </a:prstGeom>
+        </p:spPr>
+      </p:pic>
+      <p:sp>
+        <p:nvSpPr>
+          <p:cNvPr id="7" name="Text 4"/>
+          <p:cNvSpPr txBox="1"/>
+          <p:nvPr/>
+        </p:nvSpPr>
+        <p:spPr>
+          <a:xfrm>
+            <a:off x="685800" y="2651760"/>
+            <a:ext cx="2286000" cy="274320"/>
+          </a:xfrm>
+          <a:prstGeom prst="rect">
+            <a:avLst/>
+          </a:prstGeom>
+          <a:noFill/>
+          <a:ln/>
+        </p:spPr>
+        <p:txBody>
+          <a:bodyPr wrap="square" lIns="0" tIns="0" rIns="0" bIns="0" rtlCol="0" anchor="t"/>
+          <a:lstStyle/>
+          <a:p>
+            <a:pPr marL="0" indent="0">
+              <a:buNone/>
+            </a:pPr>
+            <a:r>
+              <a:rPr lang="en-US" sz="1100" b="1" kern="0" spc="200" dirty="0">
+                <a:solidFill>
+                  <a:srgbClr val="1446D6"/>
+                </a:solidFill>
+                <a:latin typeface="Calibri" pitchFamily="34" charset="0"/>
+                <a:ea typeface="Calibri" pitchFamily="34" charset="-122"/>
+                <a:cs typeface="Calibri" pitchFamily="34" charset="-120"/>
+              </a:rPr>
+              <a:t>INPUT</a:t>
+            </a:r>
+            <a:endParaRPr lang="en-US" sz="1100" dirty="0"/>
+          </a:p>
+        </p:txBody>
+      </p:sp>
+      <p:sp>
+        <p:nvSpPr>
+          <p:cNvPr id="8" name="Text 5"/>
+          <p:cNvSpPr txBox="1"/>
+          <p:nvPr/>
+        </p:nvSpPr>
+        <p:spPr>
+          <a:xfrm>
+            <a:off x="685800" y="2880360"/>
+            <a:ext cx="2286000" cy="365760"/>
+          </a:xfrm>
+          <a:prstGeom prst="rect">
+            <a:avLst/>
+          </a:prstGeom>
+          <a:noFill/>
+          <a:ln/>
+        </p:spPr>
+        <p:txBody>
+          <a:bodyPr wrap="square" lIns="0" tIns="0" rIns="0" bIns="0" rtlCol="0" anchor="t"/>
+          <a:lstStyle/>
+          <a:p>
+            <a:pPr marL="0" indent="0">
+              <a:buNone/>
+            </a:pPr>
+            <a:r>
+              <a:rPr lang="en-US" sz="2000" b="1" dirty="0">
+                <a:solidFill>
+                  <a:srgbClr val="0F1B3D"/>
+                </a:solidFill>
+                <a:latin typeface="Calibri" pitchFamily="34" charset="0"/>
+                <a:ea typeface="Calibri" pitchFamily="34" charset="-122"/>
+                <a:cs typeface="Calibri" pitchFamily="34" charset="-120"/>
+              </a:rPr>
+              <a:t>One document</a:t>
+            </a:r>
+            <a:endParaRPr lang="en-US" sz="2000" dirty="0"/>
+          </a:p>
+        </p:txBody>
+      </p:sp>
+      <p:sp>
+        <p:nvSpPr>
+          <p:cNvPr id="9" name="Text 6"/>
+          <p:cNvSpPr txBox="1"/>
+          <p:nvPr/>
+        </p:nvSpPr>
+        <p:spPr>
+          <a:xfrm>
+            <a:off x="685800" y="3218688"/>
+            <a:ext cx="2240280" cy="457200"/>
+          </a:xfrm>
+          <a:prstGeom prst="rect">
+            <a:avLst/>
+          </a:prstGeom>
+          <a:noFill/>
+          <a:ln/>
+        </p:spPr>
+        <p:txBody>
+          <a:bodyPr wrap="square" lIns="0" tIns="0" rIns="0" bIns="0" rtlCol="0" anchor="t"/>
+          <a:lstStyle/>
+          <a:p>
+            <a:pPr marL="0" indent="0">
+              <a:buNone/>
+            </a:pPr>
+            <a:r>
+              <a:rPr lang="en-US" sz="1200" dirty="0">
+                <a:solidFill>
+                  <a:srgbClr val="5B6480"/>
+                </a:solidFill>
+                <a:latin typeface="Calibri" pitchFamily="34" charset="0"/>
+                <a:ea typeface="Calibri" pitchFamily="34" charset="-122"/>
+                <a:cs typeface="Calibri" pitchFamily="34" charset="-120"/>
+              </a:rPr>
+              <a:t>PDF, DOCX or TXT: a policy, process or onboarding guide</a:t>
+            </a:r>
+            <a:endParaRPr lang="en-US" sz="1200" dirty="0"/>
+          </a:p>
+        </p:txBody>
+      </p:sp>
+      <p:sp>
+        <p:nvSpPr>
+          <p:cNvPr id="10" name="Text 7"/>
+          <p:cNvSpPr txBox="1"/>
+          <p:nvPr/>
+        </p:nvSpPr>
+        <p:spPr>
+          <a:xfrm>
+            <a:off x="3154680" y="2286000"/>
+            <a:ext cx="1371600" cy="274320"/>
+          </a:xfrm>
+          <a:prstGeom prst="rect">
+            <a:avLst/>
+          </a:prstGeom>
+          <a:noFill/>
+          <a:ln/>
+        </p:spPr>
+        <p:txBody>
+          <a:bodyPr wrap="square" lIns="0" tIns="0" rIns="0" bIns="0" rtlCol="0" anchor="t"/>
+          <a:lstStyle/>
+          <a:p>
+            <a:pPr marL="0" indent="0" algn="ctr">
+              <a:buNone/>
+            </a:pPr>
+            <a:r>
+              <a:rPr lang="en-US" sz="1200" b="1" dirty="0">
+                <a:solidFill>
+                  <a:srgbClr val="1446D6"/>
+                </a:solidFill>
+                <a:latin typeface="Calibri" pitchFamily="34" charset="0"/>
+                <a:ea typeface="Calibri" pitchFamily="34" charset="-122"/>
+                <a:cs typeface="Calibri" pitchFamily="34" charset="-120"/>
+              </a:rPr>
+              <a:t>AI · a few minutes</a:t>
+            </a:r>
+            <a:endParaRPr lang="en-US" sz="1200" dirty="0"/>
+          </a:p>
+        </p:txBody>
+      </p:sp>
+      <p:sp>
+        <p:nvSpPr>
+          <p:cNvPr id="11" name="Shape 8"/>
           <p:cNvSpPr/>
           <p:nvPr/>
         </p:nvSpPr>
         <p:spPr>
           <a:xfrm>
-            <a:off x="685800" y="1783080"/>
-            <a:ext cx="640080" cy="640080"/>
-          </a:xfrm>
-          <a:prstGeom prst="ellipse">
+            <a:off x="3520440" y="2606040"/>
+            <a:ext cx="640080" cy="365760"/>
+          </a:xfrm>
+          <a:prstGeom prst="rightArrow">
             <a:avLst/>
           </a:prstGeom>
           <a:solidFill>
@@ -1659,189 +1975,77 @@
           </a:ln>
         </p:spPr>
       </p:sp>
+      <p:sp>
+        <p:nvSpPr>
+          <p:cNvPr id="12" name="Shape 9"/>
+          <p:cNvSpPr/>
+          <p:nvPr/>
+        </p:nvSpPr>
+        <p:spPr>
+          <a:xfrm>
+            <a:off x="4572000" y="1508760"/>
+            <a:ext cx="4114800" cy="1069848"/>
+          </a:xfrm>
+          <a:prstGeom prst="roundRect">
+            <a:avLst>
+              <a:gd name="adj" fmla="val 10256"/>
+            </a:avLst>
+          </a:prstGeom>
+          <a:solidFill>
+            <a:srgbClr val="FFFFFF"/>
+          </a:solidFill>
+          <a:ln w="9525">
+            <a:solidFill>
+              <a:srgbClr val="DCE3F2"/>
+            </a:solidFill>
+            <a:prstDash val="solid"/>
+          </a:ln>
+          <a:effectLst>
+            <a:outerShdw blurRad="127000" dist="38100" dir="5400000" algn="bl" rotWithShape="0">
+              <a:srgbClr val="0F1B3D">
+                <a:alpha val="12000"/>
+              </a:srgbClr>
+            </a:outerShdw>
+          </a:effectLst>
+        </p:spPr>
+      </p:sp>
+      <p:sp>
+        <p:nvSpPr>
+          <p:cNvPr id="13" name="Shape 10"/>
+          <p:cNvSpPr/>
+          <p:nvPr/>
+        </p:nvSpPr>
+        <p:spPr>
+          <a:xfrm>
+            <a:off x="4754880" y="1682496"/>
+            <a:ext cx="731520" cy="731520"/>
+          </a:xfrm>
+          <a:prstGeom prst="roundRect">
+            <a:avLst>
+              <a:gd name="adj" fmla="val 22000"/>
+            </a:avLst>
+          </a:prstGeom>
+          <a:solidFill>
+            <a:srgbClr val="FFFFFF"/>
+          </a:solidFill>
+          <a:ln w="12700">
+            <a:solidFill>
+              <a:srgbClr val="FFFFFF"/>
+            </a:solidFill>
+            <a:prstDash val="solid"/>
+          </a:ln>
+          <a:effectLst>
+            <a:outerShdw blurRad="127000" dist="38100" dir="5400000" algn="bl" rotWithShape="0">
+              <a:srgbClr val="0F1B3D">
+                <a:alpha val="12000"/>
+              </a:srgbClr>
+            </a:outerShdw>
+          </a:effectLst>
+        </p:spPr>
+      </p:sp>
       <p:pic>
         <p:nvPicPr>
-          <p:cNvPr id="6" name="Image 0" descr="preencoded.png"/>
-          <p:cNvPicPr>
-            <a:picLocks noChangeAspect="1"/>
-          </p:cNvPicPr>
-          <p:nvPr/>
-        </p:nvPicPr>
-        <p:blipFill>
-          <a:blip r:embed="rId3"/>
-          <a:stretch>
-            <a:fillRect/>
-          </a:stretch>
-        </p:blipFill>
-        <p:spPr>
-          <a:xfrm>
-            <a:off x="845820" y="1943100"/>
-            <a:ext cx="320040" cy="320040"/>
-          </a:xfrm>
-          <a:prstGeom prst="rect">
-            <a:avLst/>
-          </a:prstGeom>
-        </p:spPr>
-      </p:pic>
-      <p:sp>
-        <p:nvSpPr>
-          <p:cNvPr id="7" name="Text 4"/>
-          <p:cNvSpPr txBox="1"/>
-          <p:nvPr/>
-        </p:nvSpPr>
-        <p:spPr>
-          <a:xfrm>
-            <a:off x="685800" y="2560320"/>
-            <a:ext cx="2286000" cy="320040"/>
-          </a:xfrm>
-          <a:prstGeom prst="rect">
-            <a:avLst/>
-          </a:prstGeom>
-          <a:noFill/>
-          <a:ln/>
-        </p:spPr>
-        <p:txBody>
-          <a:bodyPr wrap="square" lIns="0" tIns="0" rIns="0" bIns="0" rtlCol="0" anchor="ctr"/>
-          <a:lstStyle/>
-          <a:p>
-            <a:pPr marL="0" indent="0">
-              <a:buNone/>
-            </a:pPr>
-            <a:r>
-              <a:rPr lang="en-US" sz="1300" dirty="0">
-                <a:solidFill>
-                  <a:srgbClr val="5B6480"/>
-                </a:solidFill>
-                <a:latin typeface="Calibri" pitchFamily="34" charset="0"/>
-                <a:ea typeface="Calibri" pitchFamily="34" charset="-122"/>
-                <a:cs typeface="Calibri" pitchFamily="34" charset="-120"/>
-              </a:rPr>
-              <a:t>Input</a:t>
-            </a:r>
-            <a:endParaRPr lang="en-US" sz="1300" dirty="0"/>
-          </a:p>
-        </p:txBody>
-      </p:sp>
-      <p:sp>
-        <p:nvSpPr>
-          <p:cNvPr id="8" name="Text 5"/>
-          <p:cNvSpPr txBox="1"/>
-          <p:nvPr/>
-        </p:nvSpPr>
-        <p:spPr>
-          <a:xfrm>
-            <a:off x="685800" y="2834640"/>
-            <a:ext cx="2286000" cy="365760"/>
-          </a:xfrm>
-          <a:prstGeom prst="rect">
-            <a:avLst/>
-          </a:prstGeom>
-          <a:noFill/>
-          <a:ln/>
-        </p:spPr>
-        <p:txBody>
-          <a:bodyPr wrap="square" lIns="0" tIns="0" rIns="0" bIns="0" rtlCol="0" anchor="ctr"/>
-          <a:lstStyle/>
-          <a:p>
-            <a:pPr marL="0" indent="0">
-              <a:buNone/>
-            </a:pPr>
-            <a:r>
-              <a:rPr lang="en-US" sz="2000" b="1" dirty="0">
-                <a:solidFill>
-                  <a:srgbClr val="0F1B3D"/>
-                </a:solidFill>
-                <a:latin typeface="Calibri" pitchFamily="34" charset="0"/>
-                <a:ea typeface="Calibri" pitchFamily="34" charset="-122"/>
-                <a:cs typeface="Calibri" pitchFamily="34" charset="-120"/>
-              </a:rPr>
-              <a:t>One document</a:t>
-            </a:r>
-            <a:endParaRPr lang="en-US" sz="2000" dirty="0"/>
-          </a:p>
-        </p:txBody>
-      </p:sp>
-      <p:sp>
-        <p:nvSpPr>
-          <p:cNvPr id="9" name="Text 6"/>
-          <p:cNvSpPr txBox="1"/>
-          <p:nvPr/>
-        </p:nvSpPr>
-        <p:spPr>
-          <a:xfrm>
-            <a:off x="685800" y="3154680"/>
-            <a:ext cx="2286000" cy="457200"/>
-          </a:xfrm>
-          <a:prstGeom prst="rect">
-            <a:avLst/>
-          </a:prstGeom>
-          <a:noFill/>
-          <a:ln/>
-        </p:spPr>
-        <p:txBody>
-          <a:bodyPr wrap="square" lIns="0" tIns="0" rIns="0" bIns="0" rtlCol="0" anchor="ctr"/>
-          <a:lstStyle/>
-          <a:p>
-            <a:pPr marL="0" indent="0">
-              <a:buNone/>
-            </a:pPr>
-            <a:r>
-              <a:rPr lang="en-US" sz="1200" dirty="0">
-                <a:solidFill>
-                  <a:srgbClr val="5B6480"/>
-                </a:solidFill>
-                <a:latin typeface="Calibri" pitchFamily="34" charset="0"/>
-                <a:ea typeface="Calibri" pitchFamily="34" charset="-122"/>
-                <a:cs typeface="Calibri" pitchFamily="34" charset="-120"/>
-              </a:rPr>
-              <a:t>PDF, DOCX or TXT: a policy, process or onboarding guide</a:t>
-            </a:r>
-            <a:endParaRPr lang="en-US" sz="1200" dirty="0"/>
-          </a:p>
-        </p:txBody>
-      </p:sp>
-      <p:sp>
-        <p:nvSpPr>
-          <p:cNvPr id="10" name="Text 7"/>
-          <p:cNvSpPr txBox="1"/>
-          <p:nvPr/>
-        </p:nvSpPr>
-        <p:spPr>
-          <a:xfrm>
-            <a:off x="3154680" y="2240280"/>
-            <a:ext cx="1371600" cy="274320"/>
-          </a:xfrm>
-          <a:prstGeom prst="rect">
-            <a:avLst/>
-          </a:prstGeom>
-          <a:noFill/>
-          <a:ln/>
-        </p:spPr>
-        <p:txBody>
-          <a:bodyPr wrap="square" lIns="0" tIns="0" rIns="0" bIns="0" rtlCol="0" anchor="ctr"/>
-          <a:lstStyle/>
-          <a:p>
-            <a:pPr marL="0" indent="0" algn="ctr">
-              <a:buNone/>
-            </a:pPr>
-            <a:r>
-              <a:rPr lang="en-US" sz="1200" b="1" dirty="0">
-                <a:solidFill>
-                  <a:srgbClr val="1446D6"/>
-                </a:solidFill>
-                <a:latin typeface="Calibri" pitchFamily="34" charset="0"/>
-                <a:ea typeface="Calibri" pitchFamily="34" charset="-122"/>
-                <a:cs typeface="Calibri" pitchFamily="34" charset="-120"/>
-              </a:rPr>
-              <a:t>AI · a few minutes</a:t>
-            </a:r>
-            <a:endParaRPr lang="en-US" sz="1200" dirty="0"/>
-          </a:p>
-        </p:txBody>
-      </p:sp>
-      <p:pic>
-        <p:nvPicPr>
-          <p:cNvPr id="11" name="Image 1" descr="preencoded.png"/>
+          <p:cNvPr id="14" name="Image 1" descr="C:\Users\Admin\AppData\Local\Temp\claude\d--SmartTutor\5ff2c210-ed39-47c1-9187-8611ef6ccd50\scratchpad\deck\emoji\clapper.png"/>
           <p:cNvPicPr>
             <a:picLocks noChangeAspect="1"/>
           </p:cNvPicPr>
@@ -1855,8 +2059,8 @@
         </p:blipFill>
         <p:spPr>
           <a:xfrm>
-            <a:off x="3566160" y="2514600"/>
-            <a:ext cx="548640" cy="548640"/>
+            <a:off x="4871923" y="1799539"/>
+            <a:ext cx="497434" cy="497434"/>
           </a:xfrm>
           <a:prstGeom prst="rect">
             <a:avLst/>
@@ -1865,90 +2069,14 @@
       </p:pic>
       <p:sp>
         <p:nvSpPr>
-          <p:cNvPr id="12" name="Shape 8"/>
-          <p:cNvSpPr/>
-          <p:nvPr/>
-        </p:nvSpPr>
-        <p:spPr>
-          <a:xfrm>
-            <a:off x="4572000" y="1554480"/>
-            <a:ext cx="4114800" cy="960120"/>
-          </a:xfrm>
-          <a:prstGeom prst="roundRect">
-            <a:avLst>
-              <a:gd name="adj" fmla="val 11429"/>
-            </a:avLst>
-          </a:prstGeom>
-          <a:solidFill>
-            <a:srgbClr val="FFFFFF"/>
-          </a:solidFill>
-          <a:ln w="12700">
-            <a:solidFill>
-              <a:srgbClr val="C9D6F5"/>
-            </a:solidFill>
-            <a:prstDash val="solid"/>
-          </a:ln>
-        </p:spPr>
-      </p:sp>
-      <p:sp>
-        <p:nvSpPr>
-          <p:cNvPr id="13" name="Shape 9"/>
-          <p:cNvSpPr/>
-          <p:nvPr/>
-        </p:nvSpPr>
-        <p:spPr>
-          <a:xfrm>
-            <a:off x="4754880" y="1737360"/>
-            <a:ext cx="594360" cy="594360"/>
-          </a:xfrm>
-          <a:prstGeom prst="ellipse">
-            <a:avLst/>
-          </a:prstGeom>
-          <a:solidFill>
-            <a:srgbClr val="FFC845"/>
-          </a:solidFill>
-          <a:ln w="12700">
-            <a:solidFill>
-              <a:srgbClr val="FFC845"/>
-            </a:solidFill>
-            <a:prstDash val="solid"/>
-          </a:ln>
-        </p:spPr>
-      </p:sp>
-      <p:pic>
-        <p:nvPicPr>
-          <p:cNvPr id="14" name="Image 2" descr="preencoded.png"/>
-          <p:cNvPicPr>
-            <a:picLocks noChangeAspect="1"/>
-          </p:cNvPicPr>
-          <p:nvPr/>
-        </p:nvPicPr>
-        <p:blipFill>
-          <a:blip r:embed="rId5"/>
-          <a:stretch>
-            <a:fillRect/>
-          </a:stretch>
-        </p:blipFill>
-        <p:spPr>
-          <a:xfrm>
-            <a:off x="4903470" y="1885950"/>
-            <a:ext cx="297180" cy="297180"/>
-          </a:xfrm>
-          <a:prstGeom prst="rect">
-            <a:avLst/>
-          </a:prstGeom>
-        </p:spPr>
-      </p:pic>
-      <p:sp>
-        <p:nvSpPr>
-          <p:cNvPr id="15" name="Text 10"/>
+          <p:cNvPr id="15" name="Text 11"/>
           <p:cNvSpPr txBox="1"/>
           <p:nvPr/>
         </p:nvSpPr>
         <p:spPr>
           <a:xfrm>
-            <a:off x="5532120" y="1691640"/>
-            <a:ext cx="3017520" cy="365760"/>
+            <a:off x="5669280" y="1691640"/>
+            <a:ext cx="2880360" cy="365760"/>
           </a:xfrm>
           <a:prstGeom prst="rect">
             <a:avLst/>
@@ -1957,7 +2085,7 @@
           <a:ln/>
         </p:spPr>
         <p:txBody>
-          <a:bodyPr wrap="square" lIns="0" tIns="0" rIns="0" bIns="0" rtlCol="0" anchor="ctr"/>
+          <a:bodyPr wrap="square" lIns="0" tIns="0" rIns="0" bIns="0" rtlCol="0" anchor="t"/>
           <a:lstStyle/>
           <a:p>
             <a:pPr marL="0" indent="0">
@@ -1980,14 +2108,14 @@
       </p:sp>
       <p:sp>
         <p:nvSpPr>
-          <p:cNvPr id="16" name="Text 11"/>
+          <p:cNvPr id="16" name="Text 12"/>
           <p:cNvSpPr txBox="1"/>
           <p:nvPr/>
         </p:nvSpPr>
         <p:spPr>
           <a:xfrm>
-            <a:off x="5532120" y="2029968"/>
-            <a:ext cx="3017520" cy="365760"/>
+            <a:off x="5669280" y="2057400"/>
+            <a:ext cx="2880360" cy="411480"/>
           </a:xfrm>
           <a:prstGeom prst="rect">
             <a:avLst/>
@@ -1996,7 +2124,7 @@
           <a:ln/>
         </p:spPr>
         <p:txBody>
-          <a:bodyPr wrap="square" lIns="0" tIns="0" rIns="0" bIns="0" rtlCol="0" anchor="ctr"/>
+          <a:bodyPr wrap="square" lIns="0" tIns="0" rIns="0" bIns="0" rtlCol="0" anchor="t"/>
           <a:lstStyle/>
           <a:p>
             <a:pPr marL="0" indent="0">
@@ -2019,18 +2147,52 @@
       </p:sp>
       <p:sp>
         <p:nvSpPr>
-          <p:cNvPr id="17" name="Shape 12"/>
+          <p:cNvPr id="17" name="Shape 13"/>
           <p:cNvSpPr/>
           <p:nvPr/>
         </p:nvSpPr>
         <p:spPr>
           <a:xfrm>
-            <a:off x="4572000" y="2651760"/>
-            <a:ext cx="4114800" cy="960120"/>
+            <a:off x="4572000" y="2679192"/>
+            <a:ext cx="4114800" cy="1069848"/>
           </a:xfrm>
           <a:prstGeom prst="roundRect">
             <a:avLst>
-              <a:gd name="adj" fmla="val 11429"/>
+              <a:gd name="adj" fmla="val 10256"/>
+            </a:avLst>
+          </a:prstGeom>
+          <a:solidFill>
+            <a:srgbClr val="FFFFFF"/>
+          </a:solidFill>
+          <a:ln w="9525">
+            <a:solidFill>
+              <a:srgbClr val="DCE3F2"/>
+            </a:solidFill>
+            <a:prstDash val="solid"/>
+          </a:ln>
+          <a:effectLst>
+            <a:outerShdw blurRad="127000" dist="38100" dir="5400000" algn="bl" rotWithShape="0">
+              <a:srgbClr val="0F1B3D">
+                <a:alpha val="12000"/>
+              </a:srgbClr>
+            </a:outerShdw>
+          </a:effectLst>
+        </p:spPr>
+      </p:sp>
+      <p:sp>
+        <p:nvSpPr>
+          <p:cNvPr id="18" name="Shape 14"/>
+          <p:cNvSpPr/>
+          <p:nvPr/>
+        </p:nvSpPr>
+        <p:spPr>
+          <a:xfrm>
+            <a:off x="4754880" y="2852928"/>
+            <a:ext cx="731520" cy="731520"/>
+          </a:xfrm>
+          <a:prstGeom prst="roundRect">
+            <a:avLst>
+              <a:gd name="adj" fmla="val 22000"/>
             </a:avLst>
           </a:prstGeom>
           <a:solidFill>
@@ -2038,55 +2200,37 @@
           </a:solidFill>
           <a:ln w="12700">
             <a:solidFill>
-              <a:srgbClr val="C9D6F5"/>
+              <a:srgbClr val="FFFFFF"/>
             </a:solidFill>
             <a:prstDash val="solid"/>
           </a:ln>
-        </p:spPr>
-      </p:sp>
-      <p:sp>
-        <p:nvSpPr>
-          <p:cNvPr id="18" name="Shape 13"/>
-          <p:cNvSpPr/>
-          <p:nvPr/>
-        </p:nvSpPr>
-        <p:spPr>
-          <a:xfrm>
-            <a:off x="4754880" y="2834640"/>
-            <a:ext cx="594360" cy="594360"/>
-          </a:xfrm>
-          <a:prstGeom prst="ellipse">
-            <a:avLst/>
-          </a:prstGeom>
-          <a:solidFill>
-            <a:srgbClr val="FFC845"/>
-          </a:solidFill>
-          <a:ln w="12700">
-            <a:solidFill>
-              <a:srgbClr val="FFC845"/>
-            </a:solidFill>
-            <a:prstDash val="solid"/>
-          </a:ln>
+          <a:effectLst>
+            <a:outerShdw blurRad="127000" dist="38100" dir="5400000" algn="bl" rotWithShape="0">
+              <a:srgbClr val="0F1B3D">
+                <a:alpha val="12000"/>
+              </a:srgbClr>
+            </a:outerShdw>
+          </a:effectLst>
         </p:spPr>
       </p:sp>
       <p:pic>
         <p:nvPicPr>
-          <p:cNvPr id="19" name="Image 3" descr="preencoded.png"/>
+          <p:cNvPr id="19" name="Image 2" descr="C:\Users\Admin\AppData\Local\Temp\claude\d--SmartTutor\5ff2c210-ed39-47c1-9187-8611ef6ccd50\scratchpad\deck\emoji\picture.png"/>
           <p:cNvPicPr>
             <a:picLocks noChangeAspect="1"/>
           </p:cNvPicPr>
           <p:nvPr/>
         </p:nvPicPr>
         <p:blipFill>
-          <a:blip r:embed="rId6"/>
+          <a:blip r:embed="rId5"/>
           <a:stretch>
             <a:fillRect/>
           </a:stretch>
         </p:blipFill>
         <p:spPr>
           <a:xfrm>
-            <a:off x="4903470" y="2983230"/>
-            <a:ext cx="297180" cy="297180"/>
+            <a:off x="4871923" y="2969971"/>
+            <a:ext cx="497434" cy="497434"/>
           </a:xfrm>
           <a:prstGeom prst="rect">
             <a:avLst/>
@@ -2095,14 +2239,14 @@
       </p:pic>
       <p:sp>
         <p:nvSpPr>
-          <p:cNvPr id="20" name="Text 14"/>
+          <p:cNvPr id="20" name="Text 15"/>
           <p:cNvSpPr txBox="1"/>
           <p:nvPr/>
         </p:nvSpPr>
         <p:spPr>
           <a:xfrm>
-            <a:off x="5532120" y="2788920"/>
-            <a:ext cx="3017520" cy="365760"/>
+            <a:off x="5669280" y="2862072"/>
+            <a:ext cx="2880360" cy="365760"/>
           </a:xfrm>
           <a:prstGeom prst="rect">
             <a:avLst/>
@@ -2111,7 +2255,7 @@
           <a:ln/>
         </p:spPr>
         <p:txBody>
-          <a:bodyPr wrap="square" lIns="0" tIns="0" rIns="0" bIns="0" rtlCol="0" anchor="ctr"/>
+          <a:bodyPr wrap="square" lIns="0" tIns="0" rIns="0" bIns="0" rtlCol="0" anchor="t"/>
           <a:lstStyle/>
           <a:p>
             <a:pPr marL="0" indent="0">
@@ -2134,14 +2278,14 @@
       </p:sp>
       <p:sp>
         <p:nvSpPr>
-          <p:cNvPr id="21" name="Text 15"/>
+          <p:cNvPr id="21" name="Text 16"/>
           <p:cNvSpPr txBox="1"/>
           <p:nvPr/>
         </p:nvSpPr>
         <p:spPr>
           <a:xfrm>
-            <a:off x="5532120" y="3127248"/>
-            <a:ext cx="3017520" cy="365760"/>
+            <a:off x="5669280" y="3227832"/>
+            <a:ext cx="2880360" cy="411480"/>
           </a:xfrm>
           <a:prstGeom prst="rect">
             <a:avLst/>
@@ -2150,7 +2294,7 @@
           <a:ln/>
         </p:spPr>
         <p:txBody>
-          <a:bodyPr wrap="square" lIns="0" tIns="0" rIns="0" bIns="0" rtlCol="0" anchor="ctr"/>
+          <a:bodyPr wrap="square" lIns="0" tIns="0" rIns="0" bIns="0" rtlCol="0" anchor="t"/>
           <a:lstStyle/>
           <a:p>
             <a:pPr marL="0" indent="0">
@@ -2173,47 +2317,56 @@
       </p:sp>
       <p:sp>
         <p:nvSpPr>
-          <p:cNvPr id="22" name="Shape 16"/>
+          <p:cNvPr id="22" name="Shape 17"/>
           <p:cNvSpPr/>
           <p:nvPr/>
         </p:nvSpPr>
         <p:spPr>
           <a:xfrm>
             <a:off x="457200" y="4069080"/>
-            <a:ext cx="411480" cy="411480"/>
-          </a:xfrm>
-          <a:prstGeom prst="ellipse">
-            <a:avLst/>
+            <a:ext cx="457200" cy="457200"/>
+          </a:xfrm>
+          <a:prstGeom prst="roundRect">
+            <a:avLst>
+              <a:gd name="adj" fmla="val 22000"/>
+            </a:avLst>
           </a:prstGeom>
           <a:solidFill>
-            <a:srgbClr val="EAF1FF"/>
+            <a:srgbClr val="FFFFFF"/>
           </a:solidFill>
           <a:ln w="12700">
             <a:solidFill>
-              <a:srgbClr val="EAF1FF"/>
+              <a:srgbClr val="FFFFFF"/>
             </a:solidFill>
             <a:prstDash val="solid"/>
           </a:ln>
+          <a:effectLst>
+            <a:outerShdw blurRad="127000" dist="38100" dir="5400000" algn="bl" rotWithShape="0">
+              <a:srgbClr val="0F1B3D">
+                <a:alpha val="12000"/>
+              </a:srgbClr>
+            </a:outerShdw>
+          </a:effectLst>
         </p:spPr>
       </p:sp>
       <p:pic>
         <p:nvPicPr>
-          <p:cNvPr id="23" name="Image 4" descr="preencoded.png"/>
+          <p:cNvPr id="23" name="Image 3" descr="C:\Users\Admin\AppData\Local\Temp\claude\d--SmartTutor\5ff2c210-ed39-47c1-9187-8611ef6ccd50\scratchpad\deck\emoji\phone.png"/>
           <p:cNvPicPr>
             <a:picLocks noChangeAspect="1"/>
           </p:cNvPicPr>
           <p:nvPr/>
         </p:nvPicPr>
         <p:blipFill>
-          <a:blip r:embed="rId7"/>
+          <a:blip r:embed="rId6"/>
           <a:stretch>
             <a:fillRect/>
           </a:stretch>
         </p:blipFill>
         <p:spPr>
           <a:xfrm>
-            <a:off x="560070" y="4171950"/>
-            <a:ext cx="205740" cy="205740"/>
+            <a:off x="530352" y="4142232"/>
+            <a:ext cx="310896" cy="310896"/>
           </a:xfrm>
           <a:prstGeom prst="rect">
             <a:avLst/>
@@ -2222,14 +2375,14 @@
       </p:pic>
       <p:sp>
         <p:nvSpPr>
-          <p:cNvPr id="24" name="Text 17"/>
+          <p:cNvPr id="24" name="Text 18"/>
           <p:cNvSpPr txBox="1"/>
           <p:nvPr/>
         </p:nvSpPr>
         <p:spPr>
           <a:xfrm>
-            <a:off x="960120" y="4069080"/>
-            <a:ext cx="2194560" cy="411480"/>
+            <a:off x="1024128" y="4069080"/>
+            <a:ext cx="2148840" cy="457200"/>
           </a:xfrm>
           <a:prstGeom prst="rect">
             <a:avLst/>
@@ -2261,47 +2414,56 @@
       </p:sp>
       <p:sp>
         <p:nvSpPr>
-          <p:cNvPr id="25" name="Shape 18"/>
+          <p:cNvPr id="25" name="Shape 19"/>
           <p:cNvSpPr/>
           <p:nvPr/>
         </p:nvSpPr>
         <p:spPr>
           <a:xfrm>
             <a:off x="3246120" y="4069080"/>
-            <a:ext cx="411480" cy="411480"/>
-          </a:xfrm>
-          <a:prstGeom prst="ellipse">
-            <a:avLst/>
+            <a:ext cx="457200" cy="457200"/>
+          </a:xfrm>
+          <a:prstGeom prst="roundRect">
+            <a:avLst>
+              <a:gd name="adj" fmla="val 22000"/>
+            </a:avLst>
           </a:prstGeom>
           <a:solidFill>
-            <a:srgbClr val="EAF1FF"/>
+            <a:srgbClr val="FFFFFF"/>
           </a:solidFill>
           <a:ln w="12700">
             <a:solidFill>
-              <a:srgbClr val="EAF1FF"/>
+              <a:srgbClr val="FFFFFF"/>
             </a:solidFill>
             <a:prstDash val="solid"/>
           </a:ln>
+          <a:effectLst>
+            <a:outerShdw blurRad="127000" dist="38100" dir="5400000" algn="bl" rotWithShape="0">
+              <a:srgbClr val="0F1B3D">
+                <a:alpha val="12000"/>
+              </a:srgbClr>
+            </a:outerShdw>
+          </a:effectLst>
         </p:spPr>
       </p:sp>
       <p:pic>
         <p:nvPicPr>
-          <p:cNvPr id="26" name="Image 5" descr="preencoded.png"/>
+          <p:cNvPr id="26" name="Image 4" descr="C:\Users\Admin\AppData\Local\Temp\claude\d--SmartTutor\5ff2c210-ed39-47c1-9187-8611ef6ccd50\scratchpad\deck\emoji\globe.png"/>
           <p:cNvPicPr>
             <a:picLocks noChangeAspect="1"/>
           </p:cNvPicPr>
           <p:nvPr/>
         </p:nvPicPr>
         <p:blipFill>
-          <a:blip r:embed="rId8"/>
+          <a:blip r:embed="rId7"/>
           <a:stretch>
             <a:fillRect/>
           </a:stretch>
         </p:blipFill>
         <p:spPr>
           <a:xfrm>
-            <a:off x="3348990" y="4171950"/>
-            <a:ext cx="205740" cy="205740"/>
+            <a:off x="3319272" y="4142232"/>
+            <a:ext cx="310896" cy="310896"/>
           </a:xfrm>
           <a:prstGeom prst="rect">
             <a:avLst/>
@@ -2310,14 +2472,14 @@
       </p:pic>
       <p:sp>
         <p:nvSpPr>
-          <p:cNvPr id="27" name="Text 19"/>
+          <p:cNvPr id="27" name="Text 20"/>
           <p:cNvSpPr txBox="1"/>
           <p:nvPr/>
         </p:nvSpPr>
         <p:spPr>
           <a:xfrm>
-            <a:off x="3749040" y="4069080"/>
-            <a:ext cx="2194560" cy="411480"/>
+            <a:off x="3813048" y="4069080"/>
+            <a:ext cx="2148840" cy="457200"/>
           </a:xfrm>
           <a:prstGeom prst="rect">
             <a:avLst/>
@@ -2349,47 +2511,56 @@
       </p:sp>
       <p:sp>
         <p:nvSpPr>
-          <p:cNvPr id="28" name="Shape 20"/>
+          <p:cNvPr id="28" name="Shape 21"/>
           <p:cNvSpPr/>
           <p:nvPr/>
         </p:nvSpPr>
         <p:spPr>
           <a:xfrm>
             <a:off x="6035040" y="4069080"/>
-            <a:ext cx="411480" cy="411480"/>
-          </a:xfrm>
-          <a:prstGeom prst="ellipse">
-            <a:avLst/>
+            <a:ext cx="457200" cy="457200"/>
+          </a:xfrm>
+          <a:prstGeom prst="roundRect">
+            <a:avLst>
+              <a:gd name="adj" fmla="val 22000"/>
+            </a:avLst>
           </a:prstGeom>
           <a:solidFill>
-            <a:srgbClr val="EAF1FF"/>
+            <a:srgbClr val="FFFFFF"/>
           </a:solidFill>
           <a:ln w="12700">
             <a:solidFill>
-              <a:srgbClr val="EAF1FF"/>
+              <a:srgbClr val="FFFFFF"/>
             </a:solidFill>
             <a:prstDash val="solid"/>
           </a:ln>
+          <a:effectLst>
+            <a:outerShdw blurRad="127000" dist="38100" dir="5400000" algn="bl" rotWithShape="0">
+              <a:srgbClr val="0F1B3D">
+                <a:alpha val="12000"/>
+              </a:srgbClr>
+            </a:outerShdw>
+          </a:effectLst>
         </p:spPr>
       </p:sp>
       <p:pic>
         <p:nvPicPr>
-          <p:cNvPr id="29" name="Image 6" descr="preencoded.png"/>
+          <p:cNvPr id="29" name="Image 5" descr="C:\Users\Admin\AppData\Local\Temp\claude\d--SmartTutor\5ff2c210-ed39-47c1-9187-8611ef6ccd50\scratchpad\deck\emoji\coin.png"/>
           <p:cNvPicPr>
             <a:picLocks noChangeAspect="1"/>
           </p:cNvPicPr>
           <p:nvPr/>
         </p:nvPicPr>
         <p:blipFill>
-          <a:blip r:embed="rId9"/>
+          <a:blip r:embed="rId8"/>
           <a:stretch>
             <a:fillRect/>
           </a:stretch>
         </p:blipFill>
         <p:spPr>
           <a:xfrm>
-            <a:off x="6137910" y="4171950"/>
-            <a:ext cx="205740" cy="205740"/>
+            <a:off x="6108192" y="4142232"/>
+            <a:ext cx="310896" cy="310896"/>
           </a:xfrm>
           <a:prstGeom prst="rect">
             <a:avLst/>
@@ -2398,14 +2569,14 @@
       </p:pic>
       <p:sp>
         <p:nvSpPr>
-          <p:cNvPr id="30" name="Text 21"/>
+          <p:cNvPr id="30" name="Text 22"/>
           <p:cNvSpPr txBox="1"/>
           <p:nvPr/>
         </p:nvSpPr>
         <p:spPr>
           <a:xfrm>
-            <a:off x="6537960" y="4069080"/>
-            <a:ext cx="2194560" cy="411480"/>
+            <a:off x="6601968" y="4069080"/>
+            <a:ext cx="2148840" cy="457200"/>
           </a:xfrm>
           <a:prstGeom prst="rect">
             <a:avLst/>
@@ -2529,6 +2700,13 @@
           <a:prstGeom prst="rect">
             <a:avLst/>
           </a:prstGeom>
+          <a:effectLst>
+            <a:outerShdw blurRad="177800" dist="50800" dir="5400000" algn="bl" rotWithShape="0">
+              <a:srgbClr val="000000">
+                <a:alpha val="35000"/>
+              </a:srgbClr>
+            </a:outerShdw>
+          </a:effectLst>
         </p:spPr>
       </p:pic>
       <p:sp>
@@ -2555,40 +2733,48 @@
             <a:prstDash val="solid"/>
           </a:ln>
         </p:spPr>
-      </p:sp>
-      <p:pic>
-        <p:nvPicPr>
-          <p:cNvPr id="5" name="Image 1" descr="preencoded.png"/>
-          <p:cNvPicPr>
-            <a:picLocks noChangeAspect="1"/>
-          </p:cNvPicPr>
-          <p:nvPr/>
-        </p:nvPicPr>
-        <p:blipFill>
-          <a:blip r:embed="rId4"/>
-          <a:stretch>
-            <a:fillRect/>
-          </a:stretch>
-        </p:blipFill>
-        <p:spPr>
-          <a:xfrm>
-            <a:off x="2834640" y="2354580"/>
-            <a:ext cx="365760" cy="365760"/>
-          </a:xfrm>
-          <a:prstGeom prst="rect">
-            <a:avLst/>
-          </a:prstGeom>
-        </p:spPr>
-      </p:pic>
-      <p:sp>
-        <p:nvSpPr>
-          <p:cNvPr id="6" name="Text 2"/>
+        <p:txBody>
+          <a:bodyPr/>
+          <a:lstStyle/>
+          <a:p>
+            <a:endParaRPr lang="en-US" dirty="0"/>
+          </a:p>
+        </p:txBody>
+      </p:sp>
+      <p:sp>
+        <p:nvSpPr>
+          <p:cNvPr id="5" name="Shape 2"/>
+          <p:cNvSpPr/>
+          <p:nvPr/>
+        </p:nvSpPr>
+        <p:spPr>
+          <a:xfrm rot="5400000">
+            <a:off x="2862072" y="2336292"/>
+            <a:ext cx="365760" cy="402336"/>
+          </a:xfrm>
+          <a:prstGeom prst="triangle">
+            <a:avLst/>
+          </a:prstGeom>
+          <a:solidFill>
+            <a:srgbClr val="0F1B3D"/>
+          </a:solidFill>
+          <a:ln w="12700">
+            <a:solidFill>
+              <a:srgbClr val="0F1B3D"/>
+            </a:solidFill>
+            <a:prstDash val="solid"/>
+          </a:ln>
+        </p:spPr>
+      </p:sp>
+      <p:sp>
+        <p:nvSpPr>
+          <p:cNvPr id="6" name="Text 3"/>
           <p:cNvSpPr txBox="1"/>
           <p:nvPr/>
         </p:nvSpPr>
         <p:spPr>
           <a:xfrm>
-            <a:off x="457200" y="4069080"/>
+            <a:off x="457200" y="4114800"/>
             <a:ext cx="5120640" cy="274320"/>
           </a:xfrm>
           <a:prstGeom prst="rect">
@@ -2598,7 +2784,7 @@
           <a:ln/>
         </p:spPr>
         <p:txBody>
-          <a:bodyPr wrap="square" lIns="0" tIns="0" rIns="0" bIns="0" rtlCol="0" anchor="ctr"/>
+          <a:bodyPr wrap="square" lIns="0" tIns="0" rIns="0" bIns="0" rtlCol="0" anchor="t"/>
           <a:lstStyle/>
           <a:p>
             <a:pPr marL="0" indent="0">
@@ -2621,47 +2807,56 @@
       </p:sp>
       <p:sp>
         <p:nvSpPr>
-          <p:cNvPr id="7" name="Shape 3"/>
+          <p:cNvPr id="7" name="Shape 4"/>
           <p:cNvSpPr/>
           <p:nvPr/>
         </p:nvSpPr>
         <p:spPr>
           <a:xfrm>
             <a:off x="5943600" y="1097280"/>
-            <a:ext cx="502920" cy="502920"/>
-          </a:xfrm>
-          <a:prstGeom prst="ellipse">
-            <a:avLst/>
+            <a:ext cx="548640" cy="548640"/>
+          </a:xfrm>
+          <a:prstGeom prst="roundRect">
+            <a:avLst>
+              <a:gd name="adj" fmla="val 22000"/>
+            </a:avLst>
           </a:prstGeom>
           <a:solidFill>
-            <a:srgbClr val="1446D6"/>
+            <a:srgbClr val="FFFFFF"/>
           </a:solidFill>
           <a:ln w="12700">
             <a:solidFill>
-              <a:srgbClr val="1446D6"/>
+              <a:srgbClr val="FFFFFF"/>
             </a:solidFill>
             <a:prstDash val="solid"/>
           </a:ln>
+          <a:effectLst>
+            <a:outerShdw blurRad="127000" dist="38100" dir="5400000" algn="bl" rotWithShape="0">
+              <a:srgbClr val="0F1B3D">
+                <a:alpha val="12000"/>
+              </a:srgbClr>
+            </a:outerShdw>
+          </a:effectLst>
         </p:spPr>
       </p:sp>
       <p:pic>
         <p:nvPicPr>
-          <p:cNvPr id="8" name="Image 2" descr="preencoded.png"/>
+          <p:cNvPr id="8" name="Image 1" descr="C:\Users\Admin\AppData\Local\Temp\claude\d--SmartTutor\5ff2c210-ed39-47c1-9187-8611ef6ccd50\scratchpad\deck\emoji\outbox.png"/>
           <p:cNvPicPr>
             <a:picLocks noChangeAspect="1"/>
           </p:cNvPicPr>
           <p:nvPr/>
         </p:nvPicPr>
         <p:blipFill>
-          <a:blip r:embed="rId5"/>
+          <a:blip r:embed="rId4"/>
           <a:stretch>
             <a:fillRect/>
           </a:stretch>
         </p:blipFill>
         <p:spPr>
           <a:xfrm>
-            <a:off x="6069330" y="1223010"/>
-            <a:ext cx="251460" cy="251460"/>
+            <a:off x="6031382" y="1185062"/>
+            <a:ext cx="373075" cy="373075"/>
           </a:xfrm>
           <a:prstGeom prst="rect">
             <a:avLst/>
@@ -2670,14 +2865,14 @@
       </p:pic>
       <p:sp>
         <p:nvSpPr>
-          <p:cNvPr id="9" name="Text 4"/>
+          <p:cNvPr id="9" name="Text 5"/>
           <p:cNvSpPr txBox="1"/>
           <p:nvPr/>
         </p:nvSpPr>
         <p:spPr>
           <a:xfrm>
-            <a:off x="6583680" y="1078992"/>
-            <a:ext cx="2194560" cy="292608"/>
+            <a:off x="6629400" y="1115568"/>
+            <a:ext cx="2103120" cy="292608"/>
           </a:xfrm>
           <a:prstGeom prst="rect">
             <a:avLst/>
@@ -2686,7 +2881,7 @@
           <a:ln/>
         </p:spPr>
         <p:txBody>
-          <a:bodyPr wrap="square" lIns="0" tIns="0" rIns="0" bIns="0" rtlCol="0" anchor="ctr"/>
+          <a:bodyPr wrap="square" lIns="0" tIns="0" rIns="0" bIns="0" rtlCol="0" anchor="t"/>
           <a:lstStyle/>
           <a:p>
             <a:pPr marL="0" indent="0">
@@ -2709,14 +2904,14 @@
       </p:sp>
       <p:sp>
         <p:nvSpPr>
-          <p:cNvPr id="10" name="Text 5"/>
+          <p:cNvPr id="10" name="Text 6"/>
           <p:cNvSpPr txBox="1"/>
           <p:nvPr/>
         </p:nvSpPr>
         <p:spPr>
           <a:xfrm>
-            <a:off x="6583680" y="1353312"/>
-            <a:ext cx="2194560" cy="274320"/>
+            <a:off x="6629400" y="1389888"/>
+            <a:ext cx="2103120" cy="274320"/>
           </a:xfrm>
           <a:prstGeom prst="rect">
             <a:avLst/>
@@ -2725,7 +2920,7 @@
           <a:ln/>
         </p:spPr>
         <p:txBody>
-          <a:bodyPr wrap="square" lIns="0" tIns="0" rIns="0" bIns="0" rtlCol="0" anchor="ctr"/>
+          <a:bodyPr wrap="square" lIns="0" tIns="0" rIns="0" bIns="0" rtlCol="0" anchor="t"/>
           <a:lstStyle/>
           <a:p>
             <a:pPr marL="0" indent="0">
@@ -2748,47 +2943,56 @@
       </p:sp>
       <p:sp>
         <p:nvSpPr>
-          <p:cNvPr id="11" name="Shape 6"/>
+          <p:cNvPr id="11" name="Shape 7"/>
           <p:cNvSpPr/>
           <p:nvPr/>
         </p:nvSpPr>
         <p:spPr>
           <a:xfrm>
-            <a:off x="5943600" y="1828800"/>
-            <a:ext cx="502920" cy="502920"/>
-          </a:xfrm>
-          <a:prstGeom prst="ellipse">
-            <a:avLst/>
+            <a:off x="5943600" y="1847088"/>
+            <a:ext cx="548640" cy="548640"/>
+          </a:xfrm>
+          <a:prstGeom prst="roundRect">
+            <a:avLst>
+              <a:gd name="adj" fmla="val 22000"/>
+            </a:avLst>
           </a:prstGeom>
           <a:solidFill>
-            <a:srgbClr val="1446D6"/>
+            <a:srgbClr val="FFFFFF"/>
           </a:solidFill>
           <a:ln w="12700">
             <a:solidFill>
-              <a:srgbClr val="1446D6"/>
+              <a:srgbClr val="FFFFFF"/>
             </a:solidFill>
             <a:prstDash val="solid"/>
           </a:ln>
+          <a:effectLst>
+            <a:outerShdw blurRad="127000" dist="38100" dir="5400000" algn="bl" rotWithShape="0">
+              <a:srgbClr val="0F1B3D">
+                <a:alpha val="12000"/>
+              </a:srgbClr>
+            </a:outerShdw>
+          </a:effectLst>
         </p:spPr>
       </p:sp>
       <p:pic>
         <p:nvPicPr>
-          <p:cNvPr id="12" name="Image 3" descr="preencoded.png"/>
+          <p:cNvPr id="12" name="Image 2" descr="C:\Users\Admin\AppData\Local\Temp\claude\d--SmartTutor\5ff2c210-ed39-47c1-9187-8611ef6ccd50\scratchpad\deck\emoji\sparkles.png"/>
           <p:cNvPicPr>
             <a:picLocks noChangeAspect="1"/>
           </p:cNvPicPr>
           <p:nvPr/>
         </p:nvPicPr>
         <p:blipFill>
-          <a:blip r:embed="rId6"/>
+          <a:blip r:embed="rId5"/>
           <a:stretch>
             <a:fillRect/>
           </a:stretch>
         </p:blipFill>
         <p:spPr>
           <a:xfrm>
-            <a:off x="6069330" y="1954530"/>
-            <a:ext cx="251460" cy="251460"/>
+            <a:off x="6031382" y="1934870"/>
+            <a:ext cx="373075" cy="373075"/>
           </a:xfrm>
           <a:prstGeom prst="rect">
             <a:avLst/>
@@ -2797,14 +3001,14 @@
       </p:pic>
       <p:sp>
         <p:nvSpPr>
-          <p:cNvPr id="13" name="Text 7"/>
+          <p:cNvPr id="13" name="Text 8"/>
           <p:cNvSpPr txBox="1"/>
           <p:nvPr/>
         </p:nvSpPr>
         <p:spPr>
           <a:xfrm>
-            <a:off x="6583680" y="1810512"/>
-            <a:ext cx="2194560" cy="292608"/>
+            <a:off x="6629400" y="1865376"/>
+            <a:ext cx="2103120" cy="292608"/>
           </a:xfrm>
           <a:prstGeom prst="rect">
             <a:avLst/>
@@ -2813,7 +3017,7 @@
           <a:ln/>
         </p:spPr>
         <p:txBody>
-          <a:bodyPr wrap="square" lIns="0" tIns="0" rIns="0" bIns="0" rtlCol="0" anchor="ctr"/>
+          <a:bodyPr wrap="square" lIns="0" tIns="0" rIns="0" bIns="0" rtlCol="0" anchor="t"/>
           <a:lstStyle/>
           <a:p>
             <a:pPr marL="0" indent="0">
@@ -2836,14 +3040,14 @@
       </p:sp>
       <p:sp>
         <p:nvSpPr>
-          <p:cNvPr id="14" name="Text 8"/>
+          <p:cNvPr id="14" name="Text 9"/>
           <p:cNvSpPr txBox="1"/>
           <p:nvPr/>
         </p:nvSpPr>
         <p:spPr>
           <a:xfrm>
-            <a:off x="6583680" y="2084832"/>
-            <a:ext cx="2194560" cy="274320"/>
+            <a:off x="6629400" y="2139696"/>
+            <a:ext cx="2103120" cy="274320"/>
           </a:xfrm>
           <a:prstGeom prst="rect">
             <a:avLst/>
@@ -2852,7 +3056,7 @@
           <a:ln/>
         </p:spPr>
         <p:txBody>
-          <a:bodyPr wrap="square" lIns="0" tIns="0" rIns="0" bIns="0" rtlCol="0" anchor="ctr"/>
+          <a:bodyPr wrap="square" lIns="0" tIns="0" rIns="0" bIns="0" rtlCol="0" anchor="t"/>
           <a:lstStyle/>
           <a:p>
             <a:pPr marL="0" indent="0">
@@ -2875,47 +3079,56 @@
       </p:sp>
       <p:sp>
         <p:nvSpPr>
-          <p:cNvPr id="15" name="Shape 9"/>
+          <p:cNvPr id="15" name="Shape 10"/>
           <p:cNvSpPr/>
           <p:nvPr/>
         </p:nvSpPr>
         <p:spPr>
           <a:xfrm>
-            <a:off x="5943600" y="2560320"/>
-            <a:ext cx="502920" cy="502920"/>
-          </a:xfrm>
-          <a:prstGeom prst="ellipse">
-            <a:avLst/>
+            <a:off x="5943600" y="2596896"/>
+            <a:ext cx="548640" cy="548640"/>
+          </a:xfrm>
+          <a:prstGeom prst="roundRect">
+            <a:avLst>
+              <a:gd name="adj" fmla="val 22000"/>
+            </a:avLst>
           </a:prstGeom>
           <a:solidFill>
-            <a:srgbClr val="1446D6"/>
+            <a:srgbClr val="FFFFFF"/>
           </a:solidFill>
           <a:ln w="12700">
             <a:solidFill>
-              <a:srgbClr val="1446D6"/>
+              <a:srgbClr val="FFFFFF"/>
             </a:solidFill>
             <a:prstDash val="solid"/>
           </a:ln>
+          <a:effectLst>
+            <a:outerShdw blurRad="127000" dist="38100" dir="5400000" algn="bl" rotWithShape="0">
+              <a:srgbClr val="0F1B3D">
+                <a:alpha val="12000"/>
+              </a:srgbClr>
+            </a:outerShdw>
+          </a:effectLst>
         </p:spPr>
       </p:sp>
       <p:pic>
         <p:nvPicPr>
-          <p:cNvPr id="16" name="Image 4" descr="preencoded.png"/>
+          <p:cNvPr id="16" name="Image 3" descr="C:\Users\Admin\AppData\Local\Temp\claude\d--SmartTutor\5ff2c210-ed39-47c1-9187-8611ef6ccd50\scratchpad\deck\emoji\camera.png"/>
           <p:cNvPicPr>
             <a:picLocks noChangeAspect="1"/>
           </p:cNvPicPr>
           <p:nvPr/>
         </p:nvPicPr>
         <p:blipFill>
-          <a:blip r:embed="rId7"/>
+          <a:blip r:embed="rId6"/>
           <a:stretch>
             <a:fillRect/>
           </a:stretch>
         </p:blipFill>
         <p:spPr>
           <a:xfrm>
-            <a:off x="6069330" y="2686050"/>
-            <a:ext cx="251460" cy="251460"/>
+            <a:off x="6031382" y="2684678"/>
+            <a:ext cx="373075" cy="373075"/>
           </a:xfrm>
           <a:prstGeom prst="rect">
             <a:avLst/>
@@ -2924,14 +3137,14 @@
       </p:pic>
       <p:sp>
         <p:nvSpPr>
-          <p:cNvPr id="17" name="Text 10"/>
+          <p:cNvPr id="17" name="Text 11"/>
           <p:cNvSpPr txBox="1"/>
           <p:nvPr/>
         </p:nvSpPr>
         <p:spPr>
           <a:xfrm>
-            <a:off x="6583680" y="2542032"/>
-            <a:ext cx="2194560" cy="292608"/>
+            <a:off x="6629400" y="2615184"/>
+            <a:ext cx="2103120" cy="292608"/>
           </a:xfrm>
           <a:prstGeom prst="rect">
             <a:avLst/>
@@ -2940,7 +3153,7 @@
           <a:ln/>
         </p:spPr>
         <p:txBody>
-          <a:bodyPr wrap="square" lIns="0" tIns="0" rIns="0" bIns="0" rtlCol="0" anchor="ctr"/>
+          <a:bodyPr wrap="square" lIns="0" tIns="0" rIns="0" bIns="0" rtlCol="0" anchor="t"/>
           <a:lstStyle/>
           <a:p>
             <a:pPr marL="0" indent="0">
@@ -2963,14 +3176,14 @@
       </p:sp>
       <p:sp>
         <p:nvSpPr>
-          <p:cNvPr id="18" name="Text 11"/>
+          <p:cNvPr id="18" name="Text 12"/>
           <p:cNvSpPr txBox="1"/>
           <p:nvPr/>
         </p:nvSpPr>
         <p:spPr>
           <a:xfrm>
-            <a:off x="6583680" y="2816352"/>
-            <a:ext cx="2194560" cy="274320"/>
+            <a:off x="6629400" y="2889504"/>
+            <a:ext cx="2103120" cy="274320"/>
           </a:xfrm>
           <a:prstGeom prst="rect">
             <a:avLst/>
@@ -2979,7 +3192,7 @@
           <a:ln/>
         </p:spPr>
         <p:txBody>
-          <a:bodyPr wrap="square" lIns="0" tIns="0" rIns="0" bIns="0" rtlCol="0" anchor="ctr"/>
+          <a:bodyPr wrap="square" lIns="0" tIns="0" rIns="0" bIns="0" rtlCol="0" anchor="t"/>
           <a:lstStyle/>
           <a:p>
             <a:pPr marL="0" indent="0">
@@ -3002,47 +3215,56 @@
       </p:sp>
       <p:sp>
         <p:nvSpPr>
-          <p:cNvPr id="19" name="Shape 12"/>
+          <p:cNvPr id="19" name="Shape 13"/>
           <p:cNvSpPr/>
           <p:nvPr/>
         </p:nvSpPr>
         <p:spPr>
           <a:xfrm>
-            <a:off x="5943600" y="3291840"/>
-            <a:ext cx="502920" cy="502920"/>
-          </a:xfrm>
-          <a:prstGeom prst="ellipse">
-            <a:avLst/>
+            <a:off x="5943600" y="3346704"/>
+            <a:ext cx="548640" cy="548640"/>
+          </a:xfrm>
+          <a:prstGeom prst="roundRect">
+            <a:avLst>
+              <a:gd name="adj" fmla="val 22000"/>
+            </a:avLst>
           </a:prstGeom>
           <a:solidFill>
-            <a:srgbClr val="1446D6"/>
+            <a:srgbClr val="FFFFFF"/>
           </a:solidFill>
           <a:ln w="12700">
             <a:solidFill>
-              <a:srgbClr val="1446D6"/>
+              <a:srgbClr val="FFFFFF"/>
             </a:solidFill>
             <a:prstDash val="solid"/>
           </a:ln>
+          <a:effectLst>
+            <a:outerShdw blurRad="127000" dist="38100" dir="5400000" algn="bl" rotWithShape="0">
+              <a:srgbClr val="0F1B3D">
+                <a:alpha val="12000"/>
+              </a:srgbClr>
+            </a:outerShdw>
+          </a:effectLst>
         </p:spPr>
       </p:sp>
       <p:pic>
         <p:nvPicPr>
-          <p:cNvPr id="20" name="Image 5" descr="preencoded.png"/>
+          <p:cNvPr id="20" name="Image 4" descr="C:\Users\Admin\AppData\Local\Temp\claude\d--SmartTutor\5ff2c210-ed39-47c1-9187-8611ef6ccd50\scratchpad\deck\emoji\link.png"/>
           <p:cNvPicPr>
             <a:picLocks noChangeAspect="1"/>
           </p:cNvPicPr>
           <p:nvPr/>
         </p:nvPicPr>
         <p:blipFill>
-          <a:blip r:embed="rId8"/>
+          <a:blip r:embed="rId7"/>
           <a:stretch>
             <a:fillRect/>
           </a:stretch>
         </p:blipFill>
         <p:spPr>
           <a:xfrm>
-            <a:off x="6069330" y="3417570"/>
-            <a:ext cx="251460" cy="251460"/>
+            <a:off x="6031382" y="3434486"/>
+            <a:ext cx="373075" cy="373075"/>
           </a:xfrm>
           <a:prstGeom prst="rect">
             <a:avLst/>
@@ -3051,14 +3273,14 @@
       </p:pic>
       <p:sp>
         <p:nvSpPr>
-          <p:cNvPr id="21" name="Text 13"/>
+          <p:cNvPr id="21" name="Text 14"/>
           <p:cNvSpPr txBox="1"/>
           <p:nvPr/>
         </p:nvSpPr>
         <p:spPr>
           <a:xfrm>
-            <a:off x="6583680" y="3273552"/>
-            <a:ext cx="2194560" cy="292608"/>
+            <a:off x="6629400" y="3364992"/>
+            <a:ext cx="2103120" cy="292608"/>
           </a:xfrm>
           <a:prstGeom prst="rect">
             <a:avLst/>
@@ -3067,7 +3289,7 @@
           <a:ln/>
         </p:spPr>
         <p:txBody>
-          <a:bodyPr wrap="square" lIns="0" tIns="0" rIns="0" bIns="0" rtlCol="0" anchor="ctr"/>
+          <a:bodyPr wrap="square" lIns="0" tIns="0" rIns="0" bIns="0" rtlCol="0" anchor="t"/>
           <a:lstStyle/>
           <a:p>
             <a:pPr marL="0" indent="0">
@@ -3090,14 +3312,14 @@
       </p:sp>
       <p:sp>
         <p:nvSpPr>
-          <p:cNvPr id="22" name="Text 14"/>
+          <p:cNvPr id="22" name="Text 15"/>
           <p:cNvSpPr txBox="1"/>
           <p:nvPr/>
         </p:nvSpPr>
         <p:spPr>
           <a:xfrm>
-            <a:off x="6583680" y="3547872"/>
-            <a:ext cx="2194560" cy="274320"/>
+            <a:off x="6629400" y="3639312"/>
+            <a:ext cx="2103120" cy="274320"/>
           </a:xfrm>
           <a:prstGeom prst="rect">
             <a:avLst/>
@@ -3106,7 +3328,7 @@
           <a:ln/>
         </p:spPr>
         <p:txBody>
-          <a:bodyPr wrap="square" lIns="0" tIns="0" rIns="0" bIns="0" rtlCol="0" anchor="ctr"/>
+          <a:bodyPr wrap="square" lIns="0" tIns="0" rIns="0" bIns="0" rtlCol="0" anchor="t"/>
           <a:lstStyle/>
           <a:p>
             <a:pPr marL="0" indent="0">
@@ -3136,6 +3358,136 @@
 </file>
 
 <file path=ppt/slides/slide4.xml><?xml version="1.0" encoding="utf-8"?>
+<p:sld xmlns:a="http://schemas.openxmlformats.org/drawingml/2006/main" xmlns:r="http://schemas.openxmlformats.org/officeDocument/2006/relationships" xmlns:p="http://schemas.openxmlformats.org/presentationml/2006/main">
+  <p:cSld name="Slide 5">
+    <p:bg>
+      <p:bgPr>
+        <a:solidFill>
+          <a:srgbClr val="F5F8FF"/>
+        </a:solidFill>
+        <a:effectLst/>
+      </p:bgPr>
+    </p:bg>
+    <p:spTree>
+      <p:nvGrpSpPr>
+        <p:cNvPr id="1" name=""/>
+        <p:cNvGrpSpPr/>
+        <p:nvPr/>
+      </p:nvGrpSpPr>
+      <p:grpSpPr>
+        <a:xfrm>
+          <a:off x="0" y="0"/>
+          <a:ext cx="0" cy="0"/>
+          <a:chOff x="0" y="0"/>
+          <a:chExt cx="0" cy="0"/>
+        </a:xfrm>
+      </p:grpSpPr>
+      <p:sp>
+        <p:nvSpPr>
+          <p:cNvPr id="2" name="Text 0"/>
+          <p:cNvSpPr txBox="1"/>
+          <p:nvPr/>
+        </p:nvSpPr>
+        <p:spPr>
+          <a:xfrm>
+            <a:off x="457200" y="320040"/>
+            <a:ext cx="8229600" cy="640080"/>
+          </a:xfrm>
+          <a:prstGeom prst="rect">
+            <a:avLst/>
+          </a:prstGeom>
+          <a:noFill/>
+          <a:ln/>
+        </p:spPr>
+        <p:txBody>
+          <a:bodyPr wrap="square" lIns="0" tIns="0" rIns="0" bIns="0" rtlCol="0" anchor="ctr"/>
+          <a:lstStyle/>
+          <a:p>
+            <a:pPr marL="0" indent="0">
+              <a:buNone/>
+            </a:pPr>
+            <a:r>
+              <a:rPr lang="en-US" sz="3200" b="1" dirty="0">
+                <a:solidFill>
+                  <a:srgbClr val="0F1B3D"/>
+                </a:solidFill>
+                <a:latin typeface="Calibri" pitchFamily="34" charset="0"/>
+                <a:ea typeface="Calibri" pitchFamily="34" charset="-122"/>
+                <a:cs typeface="Calibri" pitchFamily="34" charset="-120"/>
+              </a:rPr>
+              <a:t>System architecture</a:t>
+            </a:r>
+            <a:endParaRPr lang="en-US" sz="3200" dirty="0"/>
+          </a:p>
+        </p:txBody>
+      </p:sp>
+      <p:sp>
+        <p:nvSpPr>
+          <p:cNvPr id="3" name="Shape 1"/>
+          <p:cNvSpPr/>
+          <p:nvPr/>
+        </p:nvSpPr>
+        <p:spPr>
+          <a:xfrm>
+            <a:off x="457200" y="960120"/>
+            <a:ext cx="8229600" cy="3931920"/>
+          </a:xfrm>
+          <a:prstGeom prst="roundRect">
+            <a:avLst>
+              <a:gd name="adj" fmla="val 2791"/>
+            </a:avLst>
+          </a:prstGeom>
+          <a:solidFill>
+            <a:srgbClr val="FFFFFF"/>
+          </a:solidFill>
+          <a:ln w="9525">
+            <a:solidFill>
+              <a:srgbClr val="DCE3F2"/>
+            </a:solidFill>
+            <a:prstDash val="solid"/>
+          </a:ln>
+          <a:effectLst>
+            <a:outerShdw blurRad="127000" dist="38100" dir="5400000" algn="bl" rotWithShape="0">
+              <a:srgbClr val="0F1B3D">
+                <a:alpha val="12000"/>
+              </a:srgbClr>
+            </a:outerShdw>
+          </a:effectLst>
+        </p:spPr>
+      </p:sp>
+      <p:pic>
+        <p:nvPicPr>
+          <p:cNvPr id="4" name="Image 0" descr="D:\SmartTutor\docs\system-architecture.png"/>
+          <p:cNvPicPr>
+            <a:picLocks noChangeAspect="1"/>
+          </p:cNvPicPr>
+          <p:nvPr/>
+        </p:nvPicPr>
+        <p:blipFill>
+          <a:blip r:embed="rId3"/>
+          <a:stretch>
+            <a:fillRect/>
+          </a:stretch>
+        </p:blipFill>
+        <p:spPr>
+          <a:xfrm>
+            <a:off x="594360" y="1051560"/>
+            <a:ext cx="7955280" cy="3778758"/>
+          </a:xfrm>
+          <a:prstGeom prst="rect">
+            <a:avLst/>
+          </a:prstGeom>
+        </p:spPr>
+      </p:pic>
+    </p:spTree>
+  </p:cSld>
+  <p:clrMapOvr>
+    <a:masterClrMapping/>
+  </p:clrMapOvr>
+</p:sld>
+</file>
+
+<file path=ppt/slides/slide5.xml><?xml version="1.0" encoding="utf-8"?>
 <p:sld xmlns:a="http://schemas.openxmlformats.org/drawingml/2006/main" xmlns:r="http://schemas.openxmlformats.org/officeDocument/2006/relationships" xmlns:p="http://schemas.openxmlformats.org/presentationml/2006/main">
   <p:cSld name="Slide 4">
     <p:bg>
@@ -3192,13 +3544,13 @@
 </p:sld>
 </file>
 
-<file path=ppt/slides/slide5.xml><?xml version="1.0" encoding="utf-8"?>
+<file path=ppt/slides/slide6.xml><?xml version="1.0" encoding="utf-8"?>
 <p:sld xmlns:a="http://schemas.openxmlformats.org/drawingml/2006/main" xmlns:r="http://schemas.openxmlformats.org/officeDocument/2006/relationships" xmlns:p="http://schemas.openxmlformats.org/presentationml/2006/main">
-  <p:cSld name="Slide 5">
+  <p:cSld name="Slide 6">
     <p:bg>
       <p:bgPr>
         <a:solidFill>
-          <a:srgbClr val="FFFFFF"/>
+          <a:srgbClr val="F5F8FF"/>
         </a:solidFill>
         <a:effectLst/>
       </p:bgPr>
@@ -3250,15 +3602,83 @@
                 <a:ea typeface="Calibri" pitchFamily="34" charset="-122"/>
                 <a:cs typeface="Calibri" pitchFamily="34" charset="-120"/>
               </a:rPr>
-              <a:t>System architecture</a:t>
+              <a:t>Three key decisions</a:t>
             </a:r>
             <a:endParaRPr lang="en-US" sz="3200" dirty="0"/>
           </a:p>
         </p:txBody>
+      </p:sp>
+      <p:sp>
+        <p:nvSpPr>
+          <p:cNvPr id="3" name="Shape 1"/>
+          <p:cNvSpPr/>
+          <p:nvPr/>
+        </p:nvSpPr>
+        <p:spPr>
+          <a:xfrm>
+            <a:off x="457200" y="1188720"/>
+            <a:ext cx="2606040" cy="3017520"/>
+          </a:xfrm>
+          <a:prstGeom prst="roundRect">
+            <a:avLst>
+              <a:gd name="adj" fmla="val 4211"/>
+            </a:avLst>
+          </a:prstGeom>
+          <a:solidFill>
+            <a:srgbClr val="FFFFFF"/>
+          </a:solidFill>
+          <a:ln w="9525">
+            <a:solidFill>
+              <a:srgbClr val="DCE3F2"/>
+            </a:solidFill>
+            <a:prstDash val="solid"/>
+          </a:ln>
+          <a:effectLst>
+            <a:outerShdw blurRad="127000" dist="38100" dir="5400000" algn="bl" rotWithShape="0">
+              <a:srgbClr val="0F1B3D">
+                <a:alpha val="12000"/>
+              </a:srgbClr>
+            </a:outerShdw>
+          </a:effectLst>
+        </p:spPr>
+      </p:sp>
+      <p:sp>
+        <p:nvSpPr>
+          <p:cNvPr id="4" name="Shape 2"/>
+          <p:cNvSpPr/>
+          <p:nvPr/>
+        </p:nvSpPr>
+        <p:spPr>
+          <a:xfrm>
+            <a:off x="731520" y="1444752"/>
+            <a:ext cx="822960" cy="822960"/>
+          </a:xfrm>
+          <a:prstGeom prst="roundRect">
+            <a:avLst>
+              <a:gd name="adj" fmla="val 22000"/>
+            </a:avLst>
+          </a:prstGeom>
+          <a:solidFill>
+            <a:srgbClr val="FFFFFF"/>
+          </a:solidFill>
+          <a:ln w="12700">
+            <a:solidFill>
+              <a:srgbClr val="FFFFFF"/>
+            </a:solidFill>
+            <a:prstDash val="solid"/>
+          </a:ln>
+          <a:effectLst>
+            <a:outerShdw blurRad="127000" dist="38100" dir="5400000" algn="bl" rotWithShape="0">
+              <a:srgbClr val="0F1B3D">
+                <a:alpha val="12000"/>
+              </a:srgbClr>
+            </a:outerShdw>
+          </a:effectLst>
+        </p:spPr>
       </p:sp>
       <p:pic>
         <p:nvPicPr>
-          <p:cNvPr id="3" name="Image 0" descr="D:\SmartTutor\docs\system-architecture.png"/>
+          <p:cNvPr id="5" name="Image 0" descr="C:\Users\Admin\AppData\Local\Temp\claude\d--SmartTutor\5ff2c210-ed39-47c1-9187-8611ef6ccd50\scratchpad\deck\emoji\palette.png"/>
           <p:cNvPicPr>
             <a:picLocks noChangeAspect="1"/>
           </p:cNvPicPr>
@@ -3272,14 +3692,432 @@
         </p:blipFill>
         <p:spPr>
           <a:xfrm>
-            <a:off x="548640" y="960120"/>
-            <a:ext cx="8046720" cy="4023360"/>
+            <a:off x="863194" y="1576426"/>
+            <a:ext cx="559613" cy="559613"/>
           </a:xfrm>
           <a:prstGeom prst="rect">
             <a:avLst/>
           </a:prstGeom>
         </p:spPr>
       </p:pic>
+      <p:sp>
+        <p:nvSpPr>
+          <p:cNvPr id="6" name="Text 3"/>
+          <p:cNvSpPr txBox="1"/>
+          <p:nvPr/>
+        </p:nvSpPr>
+        <p:spPr>
+          <a:xfrm>
+            <a:off x="731520" y="2468880"/>
+            <a:ext cx="2103120" cy="640080"/>
+          </a:xfrm>
+          <a:prstGeom prst="rect">
+            <a:avLst/>
+          </a:prstGeom>
+          <a:noFill/>
+          <a:ln/>
+        </p:spPr>
+        <p:txBody>
+          <a:bodyPr wrap="square" lIns="0" tIns="0" rIns="0" bIns="0" rtlCol="0" anchor="t"/>
+          <a:lstStyle/>
+          <a:p>
+            <a:pPr marL="0" indent="0">
+              <a:buNone/>
+            </a:pPr>
+            <a:r>
+              <a:rPr lang="en-US" sz="1800" b="1" dirty="0">
+                <a:solidFill>
+                  <a:srgbClr val="0F1B3D"/>
+                </a:solidFill>
+                <a:latin typeface="Calibri" pitchFamily="34" charset="0"/>
+                <a:ea typeface="Calibri" pitchFamily="34" charset="-122"/>
+                <a:cs typeface="Calibri" pitchFamily="34" charset="-120"/>
+              </a:rPr>
+              <a:t>AI writes, code designs</a:t>
+            </a:r>
+            <a:endParaRPr lang="en-US" sz="1800" dirty="0"/>
+          </a:p>
+        </p:txBody>
+      </p:sp>
+      <p:sp>
+        <p:nvSpPr>
+          <p:cNvPr id="7" name="Text 4"/>
+          <p:cNvSpPr txBox="1"/>
+          <p:nvPr/>
+        </p:nvSpPr>
+        <p:spPr>
+          <a:xfrm>
+            <a:off x="731520" y="3108960"/>
+            <a:ext cx="2103120" cy="1005840"/>
+          </a:xfrm>
+          <a:prstGeom prst="rect">
+            <a:avLst/>
+          </a:prstGeom>
+          <a:noFill/>
+          <a:ln/>
+        </p:spPr>
+        <p:txBody>
+          <a:bodyPr wrap="square" lIns="0" tIns="0" rIns="0" bIns="0" rtlCol="0" anchor="t"/>
+          <a:lstStyle/>
+          <a:p>
+            <a:pPr marL="0" indent="0">
+              <a:buNone/>
+            </a:pPr>
+            <a:r>
+              <a:rPr lang="en-US" sz="1250" dirty="0">
+                <a:solidFill>
+                  <a:srgbClr val="5B6480"/>
+                </a:solidFill>
+                <a:latin typeface="Calibri" pitchFamily="34" charset="0"/>
+                <a:ea typeface="Calibri" pitchFamily="34" charset="-122"/>
+                <a:cs typeface="Calibri" pitchFamily="34" charset="-120"/>
+              </a:rPr>
+              <a:t>The AI only produces structured content. Templates render every word, so text is always correct and the result looks designed.</a:t>
+            </a:r>
+            <a:endParaRPr lang="en-US" sz="1250" dirty="0"/>
+          </a:p>
+        </p:txBody>
+      </p:sp>
+      <p:sp>
+        <p:nvSpPr>
+          <p:cNvPr id="8" name="Shape 5"/>
+          <p:cNvSpPr/>
+          <p:nvPr/>
+        </p:nvSpPr>
+        <p:spPr>
+          <a:xfrm>
+            <a:off x="3291840" y="1188720"/>
+            <a:ext cx="2606040" cy="3017520"/>
+          </a:xfrm>
+          <a:prstGeom prst="roundRect">
+            <a:avLst>
+              <a:gd name="adj" fmla="val 4211"/>
+            </a:avLst>
+          </a:prstGeom>
+          <a:solidFill>
+            <a:srgbClr val="FFFFFF"/>
+          </a:solidFill>
+          <a:ln w="9525">
+            <a:solidFill>
+              <a:srgbClr val="DCE3F2"/>
+            </a:solidFill>
+            <a:prstDash val="solid"/>
+          </a:ln>
+          <a:effectLst>
+            <a:outerShdw blurRad="127000" dist="38100" dir="5400000" algn="bl" rotWithShape="0">
+              <a:srgbClr val="0F1B3D">
+                <a:alpha val="12000"/>
+              </a:srgbClr>
+            </a:outerShdw>
+          </a:effectLst>
+        </p:spPr>
+      </p:sp>
+      <p:sp>
+        <p:nvSpPr>
+          <p:cNvPr id="9" name="Shape 6"/>
+          <p:cNvSpPr/>
+          <p:nvPr/>
+        </p:nvSpPr>
+        <p:spPr>
+          <a:xfrm>
+            <a:off x="3566160" y="1444752"/>
+            <a:ext cx="822960" cy="822960"/>
+          </a:xfrm>
+          <a:prstGeom prst="roundRect">
+            <a:avLst>
+              <a:gd name="adj" fmla="val 22000"/>
+            </a:avLst>
+          </a:prstGeom>
+          <a:solidFill>
+            <a:srgbClr val="FFFFFF"/>
+          </a:solidFill>
+          <a:ln w="12700">
+            <a:solidFill>
+              <a:srgbClr val="FFFFFF"/>
+            </a:solidFill>
+            <a:prstDash val="solid"/>
+          </a:ln>
+          <a:effectLst>
+            <a:outerShdw blurRad="127000" dist="38100" dir="5400000" algn="bl" rotWithShape="0">
+              <a:srgbClr val="0F1B3D">
+                <a:alpha val="12000"/>
+              </a:srgbClr>
+            </a:outerShdw>
+          </a:effectLst>
+        </p:spPr>
+      </p:sp>
+      <p:pic>
+        <p:nvPicPr>
+          <p:cNvPr id="10" name="Image 1" descr="C:\Users\Admin\AppData\Local\Temp\claude\d--SmartTutor\5ff2c210-ed39-47c1-9187-8611ef6ccd50\scratchpad\deck\emoji\film.png"/>
+          <p:cNvPicPr>
+            <a:picLocks noChangeAspect="1"/>
+          </p:cNvPicPr>
+          <p:nvPr/>
+        </p:nvPicPr>
+        <p:blipFill>
+          <a:blip r:embed="rId4"/>
+          <a:stretch>
+            <a:fillRect/>
+          </a:stretch>
+        </p:blipFill>
+        <p:spPr>
+          <a:xfrm>
+            <a:off x="3697834" y="1576426"/>
+            <a:ext cx="559613" cy="559613"/>
+          </a:xfrm>
+          <a:prstGeom prst="rect">
+            <a:avLst/>
+          </a:prstGeom>
+        </p:spPr>
+      </p:pic>
+      <p:sp>
+        <p:nvSpPr>
+          <p:cNvPr id="11" name="Text 7"/>
+          <p:cNvSpPr txBox="1"/>
+          <p:nvPr/>
+        </p:nvSpPr>
+        <p:spPr>
+          <a:xfrm>
+            <a:off x="3566160" y="2468880"/>
+            <a:ext cx="2103120" cy="640080"/>
+          </a:xfrm>
+          <a:prstGeom prst="rect">
+            <a:avLst/>
+          </a:prstGeom>
+          <a:noFill/>
+          <a:ln/>
+        </p:spPr>
+        <p:txBody>
+          <a:bodyPr wrap="square" lIns="0" tIns="0" rIns="0" bIns="0" rtlCol="0" anchor="t"/>
+          <a:lstStyle/>
+          <a:p>
+            <a:pPr marL="0" indent="0">
+              <a:buNone/>
+            </a:pPr>
+            <a:r>
+              <a:rPr lang="en-US" sz="1800" b="1" dirty="0">
+                <a:solidFill>
+                  <a:srgbClr val="0F1B3D"/>
+                </a:solidFill>
+                <a:latin typeface="Calibri" pitchFamily="34" charset="0"/>
+                <a:ea typeface="Calibri" pitchFamily="34" charset="-122"/>
+                <a:cs typeface="Calibri" pitchFamily="34" charset="-120"/>
+              </a:rPr>
+              <a:t>Real footage over AI video</a:t>
+            </a:r>
+            <a:endParaRPr lang="en-US" sz="1800" dirty="0"/>
+          </a:p>
+        </p:txBody>
+      </p:sp>
+      <p:sp>
+        <p:nvSpPr>
+          <p:cNvPr id="12" name="Text 8"/>
+          <p:cNvSpPr txBox="1"/>
+          <p:nvPr/>
+        </p:nvSpPr>
+        <p:spPr>
+          <a:xfrm>
+            <a:off x="3566160" y="3108960"/>
+            <a:ext cx="2103120" cy="1005840"/>
+          </a:xfrm>
+          <a:prstGeom prst="rect">
+            <a:avLst/>
+          </a:prstGeom>
+          <a:noFill/>
+          <a:ln/>
+        </p:spPr>
+        <p:txBody>
+          <a:bodyPr wrap="square" lIns="0" tIns="0" rIns="0" bIns="0" rtlCol="0" anchor="t"/>
+          <a:lstStyle/>
+          <a:p>
+            <a:pPr marL="0" indent="0">
+              <a:buNone/>
+            </a:pPr>
+            <a:r>
+              <a:rPr lang="en-US" sz="1250" dirty="0">
+                <a:solidFill>
+                  <a:srgbClr val="5B6480"/>
+                </a:solidFill>
+                <a:latin typeface="Calibri" pitchFamily="34" charset="0"/>
+                <a:ea typeface="Calibri" pitchFamily="34" charset="-122"/>
+                <a:cs typeface="Calibri" pitchFamily="34" charset="-120"/>
+              </a:rPr>
+              <a:t>We tested Google Veo: impressive, but hundreds of times more expensive and quota-limited. Veo stays available behind one setting.</a:t>
+            </a:r>
+            <a:endParaRPr lang="en-US" sz="1250" dirty="0"/>
+          </a:p>
+        </p:txBody>
+      </p:sp>
+      <p:sp>
+        <p:nvSpPr>
+          <p:cNvPr id="13" name="Shape 9"/>
+          <p:cNvSpPr/>
+          <p:nvPr/>
+        </p:nvSpPr>
+        <p:spPr>
+          <a:xfrm>
+            <a:off x="6126480" y="1188720"/>
+            <a:ext cx="2606040" cy="3017520"/>
+          </a:xfrm>
+          <a:prstGeom prst="roundRect">
+            <a:avLst>
+              <a:gd name="adj" fmla="val 4211"/>
+            </a:avLst>
+          </a:prstGeom>
+          <a:solidFill>
+            <a:srgbClr val="FFFFFF"/>
+          </a:solidFill>
+          <a:ln w="9525">
+            <a:solidFill>
+              <a:srgbClr val="DCE3F2"/>
+            </a:solidFill>
+            <a:prstDash val="solid"/>
+          </a:ln>
+          <a:effectLst>
+            <a:outerShdw blurRad="127000" dist="38100" dir="5400000" algn="bl" rotWithShape="0">
+              <a:srgbClr val="0F1B3D">
+                <a:alpha val="12000"/>
+              </a:srgbClr>
+            </a:outerShdw>
+          </a:effectLst>
+        </p:spPr>
+      </p:sp>
+      <p:sp>
+        <p:nvSpPr>
+          <p:cNvPr id="14" name="Shape 10"/>
+          <p:cNvSpPr/>
+          <p:nvPr/>
+        </p:nvSpPr>
+        <p:spPr>
+          <a:xfrm>
+            <a:off x="6400800" y="1444752"/>
+            <a:ext cx="822960" cy="822960"/>
+          </a:xfrm>
+          <a:prstGeom prst="roundRect">
+            <a:avLst>
+              <a:gd name="adj" fmla="val 22000"/>
+            </a:avLst>
+          </a:prstGeom>
+          <a:solidFill>
+            <a:srgbClr val="FFFFFF"/>
+          </a:solidFill>
+          <a:ln w="12700">
+            <a:solidFill>
+              <a:srgbClr val="FFFFFF"/>
+            </a:solidFill>
+            <a:prstDash val="solid"/>
+          </a:ln>
+          <a:effectLst>
+            <a:outerShdw blurRad="127000" dist="38100" dir="5400000" algn="bl" rotWithShape="0">
+              <a:srgbClr val="0F1B3D">
+                <a:alpha val="12000"/>
+              </a:srgbClr>
+            </a:outerShdw>
+          </a:effectLst>
+        </p:spPr>
+      </p:sp>
+      <p:pic>
+        <p:nvPicPr>
+          <p:cNvPr id="15" name="Image 2" descr="C:\Users\Admin\AppData\Local\Temp\claude\d--SmartTutor\5ff2c210-ed39-47c1-9187-8611ef6ccd50\scratchpad\deck\emoji\buoy.png"/>
+          <p:cNvPicPr>
+            <a:picLocks noChangeAspect="1"/>
+          </p:cNvPicPr>
+          <p:nvPr/>
+        </p:nvPicPr>
+        <p:blipFill>
+          <a:blip r:embed="rId5"/>
+          <a:stretch>
+            <a:fillRect/>
+          </a:stretch>
+        </p:blipFill>
+        <p:spPr>
+          <a:xfrm>
+            <a:off x="6532474" y="1576426"/>
+            <a:ext cx="559613" cy="559613"/>
+          </a:xfrm>
+          <a:prstGeom prst="rect">
+            <a:avLst/>
+          </a:prstGeom>
+        </p:spPr>
+      </p:pic>
+      <p:sp>
+        <p:nvSpPr>
+          <p:cNvPr id="16" name="Text 11"/>
+          <p:cNvSpPr txBox="1"/>
+          <p:nvPr/>
+        </p:nvSpPr>
+        <p:spPr>
+          <a:xfrm>
+            <a:off x="6400800" y="2468880"/>
+            <a:ext cx="2103120" cy="640080"/>
+          </a:xfrm>
+          <a:prstGeom prst="rect">
+            <a:avLst/>
+          </a:prstGeom>
+          <a:noFill/>
+          <a:ln/>
+        </p:spPr>
+        <p:txBody>
+          <a:bodyPr wrap="square" lIns="0" tIns="0" rIns="0" bIns="0" rtlCol="0" anchor="t"/>
+          <a:lstStyle/>
+          <a:p>
+            <a:pPr marL="0" indent="0">
+              <a:buNone/>
+            </a:pPr>
+            <a:r>
+              <a:rPr lang="en-US" sz="1800" b="1" dirty="0">
+                <a:solidFill>
+                  <a:srgbClr val="0F1B3D"/>
+                </a:solidFill>
+                <a:latin typeface="Calibri" pitchFamily="34" charset="0"/>
+                <a:ea typeface="Calibri" pitchFamily="34" charset="-122"/>
+                <a:cs typeface="Calibri" pitchFamily="34" charset="-120"/>
+              </a:rPr>
+              <a:t>A fallback for every step</a:t>
+            </a:r>
+            <a:endParaRPr lang="en-US" sz="1800" dirty="0"/>
+          </a:p>
+        </p:txBody>
+      </p:sp>
+      <p:sp>
+        <p:nvSpPr>
+          <p:cNvPr id="17" name="Text 12"/>
+          <p:cNvSpPr txBox="1"/>
+          <p:nvPr/>
+        </p:nvSpPr>
+        <p:spPr>
+          <a:xfrm>
+            <a:off x="6400800" y="3108960"/>
+            <a:ext cx="2103120" cy="1005840"/>
+          </a:xfrm>
+          <a:prstGeom prst="rect">
+            <a:avLst/>
+          </a:prstGeom>
+          <a:noFill/>
+          <a:ln/>
+        </p:spPr>
+        <p:txBody>
+          <a:bodyPr wrap="square" lIns="0" tIns="0" rIns="0" bIns="0" rtlCol="0" anchor="t"/>
+          <a:lstStyle/>
+          <a:p>
+            <a:pPr marL="0" indent="0">
+              <a:buNone/>
+            </a:pPr>
+            <a:r>
+              <a:rPr lang="en-US" sz="1250" dirty="0">
+                <a:solidFill>
+                  <a:srgbClr val="5B6480"/>
+                </a:solidFill>
+                <a:latin typeface="Calibri" pitchFamily="34" charset="0"/>
+                <a:ea typeface="Calibri" pitchFamily="34" charset="-122"/>
+                <a:cs typeface="Calibri" pitchFamily="34" charset="-120"/>
+              </a:rPr>
+              <a:t>Voice falls back to free Microsoft voices, the renderer to a simpler engine. Running out of quota still produces a video.</a:t>
+            </a:r>
+            <a:endParaRPr lang="en-US" sz="1250" dirty="0"/>
+          </a:p>
+        </p:txBody>
+      </p:sp>
     </p:spTree>
   </p:cSld>
   <p:clrMapOvr>
@@ -3288,13 +4126,13 @@
 </p:sld>
 </file>
 
-<file path=ppt/slides/slide6.xml><?xml version="1.0" encoding="utf-8"?>
+<file path=ppt/slides/slide7.xml><?xml version="1.0" encoding="utf-8"?>
 <p:sld xmlns:a="http://schemas.openxmlformats.org/drawingml/2006/main" xmlns:r="http://schemas.openxmlformats.org/officeDocument/2006/relationships" xmlns:p="http://schemas.openxmlformats.org/presentationml/2006/main">
-  <p:cSld name="Slide 6">
+  <p:cSld name="Slide 8">
     <p:bg>
       <p:bgPr>
         <a:solidFill>
-          <a:srgbClr val="FFFFFF"/>
+          <a:srgbClr val="F5F8FF"/>
         </a:solidFill>
         <a:effectLst/>
       </p:bgPr>
@@ -3346,7 +4184,7 @@
                 <a:ea typeface="Calibri" pitchFamily="34" charset="-122"/>
                 <a:cs typeface="Calibri" pitchFamily="34" charset="-120"/>
               </a:rPr>
-              <a:t>Three key decisions</a:t>
+              <a:t>Current limitations</a:t>
             </a:r>
             <a:endParaRPr lang="en-US" sz="3200" dirty="0"/>
           </a:p>
@@ -3360,53 +4198,69 @@
         </p:nvSpPr>
         <p:spPr>
           <a:xfrm>
-            <a:off x="457200" y="1188720"/>
-            <a:ext cx="2606040" cy="2926080"/>
+            <a:off x="457200" y="1097280"/>
+            <a:ext cx="4023360" cy="1600200"/>
           </a:xfrm>
           <a:prstGeom prst="roundRect">
             <a:avLst>
-              <a:gd name="adj" fmla="val 4211"/>
+              <a:gd name="adj" fmla="val 6857"/>
             </a:avLst>
           </a:prstGeom>
           <a:solidFill>
-            <a:srgbClr val="EAF1FF"/>
+            <a:srgbClr val="FFFFFF"/>
+          </a:solidFill>
+          <a:ln w="9525">
+            <a:solidFill>
+              <a:srgbClr val="DCE3F2"/>
+            </a:solidFill>
+            <a:prstDash val="solid"/>
+          </a:ln>
+          <a:effectLst>
+            <a:outerShdw blurRad="127000" dist="38100" dir="5400000" algn="bl" rotWithShape="0">
+              <a:srgbClr val="0F1B3D">
+                <a:alpha val="12000"/>
+              </a:srgbClr>
+            </a:outerShdw>
+          </a:effectLst>
+        </p:spPr>
+      </p:sp>
+      <p:sp>
+        <p:nvSpPr>
+          <p:cNvPr id="4" name="Shape 2"/>
+          <p:cNvSpPr/>
+          <p:nvPr/>
+        </p:nvSpPr>
+        <p:spPr>
+          <a:xfrm>
+            <a:off x="685800" y="1325880"/>
+            <a:ext cx="640080" cy="640080"/>
+          </a:xfrm>
+          <a:prstGeom prst="roundRect">
+            <a:avLst>
+              <a:gd name="adj" fmla="val 22000"/>
+            </a:avLst>
+          </a:prstGeom>
+          <a:solidFill>
+            <a:srgbClr val="FFFFFF"/>
           </a:solidFill>
           <a:ln w="12700">
             <a:solidFill>
-              <a:srgbClr val="EAF1FF"/>
+              <a:srgbClr val="FFFFFF"/>
             </a:solidFill>
             <a:prstDash val="solid"/>
           </a:ln>
-        </p:spPr>
-      </p:sp>
-      <p:sp>
-        <p:nvSpPr>
-          <p:cNvPr id="4" name="Shape 2"/>
-          <p:cNvSpPr/>
-          <p:nvPr/>
-        </p:nvSpPr>
-        <p:spPr>
-          <a:xfrm>
-            <a:off x="731520" y="1463040"/>
-            <a:ext cx="731520" cy="731520"/>
-          </a:xfrm>
-          <a:prstGeom prst="ellipse">
-            <a:avLst/>
-          </a:prstGeom>
-          <a:solidFill>
-            <a:srgbClr val="1446D6"/>
-          </a:solidFill>
-          <a:ln w="12700">
-            <a:solidFill>
-              <a:srgbClr val="1446D6"/>
-            </a:solidFill>
-            <a:prstDash val="solid"/>
-          </a:ln>
+          <a:effectLst>
+            <a:outerShdw blurRad="127000" dist="38100" dir="5400000" algn="bl" rotWithShape="0">
+              <a:srgbClr val="0F1B3D">
+                <a:alpha val="12000"/>
+              </a:srgbClr>
+            </a:outerShdw>
+          </a:effectLst>
         </p:spPr>
       </p:sp>
       <p:pic>
         <p:nvPicPr>
-          <p:cNvPr id="5" name="Image 0" descr="preencoded.png"/>
+          <p:cNvPr id="5" name="Image 0" descr="C:\Users\Admin\AppData\Local\Temp\claude\d--SmartTutor\5ff2c210-ed39-47c1-9187-8611ef6ccd50\scratchpad\deck\emoji\laptop.png"/>
           <p:cNvPicPr>
             <a:picLocks noChangeAspect="1"/>
           </p:cNvPicPr>
@@ -3420,8 +4274,8 @@
         </p:blipFill>
         <p:spPr>
           <a:xfrm>
-            <a:off x="914400" y="1645920"/>
-            <a:ext cx="365760" cy="365760"/>
+            <a:off x="788213" y="1428293"/>
+            <a:ext cx="435254" cy="435254"/>
           </a:xfrm>
           <a:prstGeom prst="rect">
             <a:avLst/>
@@ -3436,8 +4290,8 @@
         </p:nvSpPr>
         <p:spPr>
           <a:xfrm>
-            <a:off x="731520" y="2377440"/>
-            <a:ext cx="2103120" cy="640080"/>
+            <a:off x="1508760" y="1298448"/>
+            <a:ext cx="2834640" cy="347472"/>
           </a:xfrm>
           <a:prstGeom prst="rect">
             <a:avLst/>
@@ -3447,540 +4301,6 @@
         </p:spPr>
         <p:txBody>
           <a:bodyPr wrap="square" lIns="0" tIns="0" rIns="0" bIns="0" rtlCol="0" anchor="t"/>
-          <a:lstStyle/>
-          <a:p>
-            <a:pPr marL="0" indent="0">
-              <a:buNone/>
-            </a:pPr>
-            <a:r>
-              <a:rPr lang="en-US" sz="1800" b="1" dirty="0">
-                <a:solidFill>
-                  <a:srgbClr val="0F1B3D"/>
-                </a:solidFill>
-                <a:latin typeface="Calibri" pitchFamily="34" charset="0"/>
-                <a:ea typeface="Calibri" pitchFamily="34" charset="-122"/>
-                <a:cs typeface="Calibri" pitchFamily="34" charset="-120"/>
-              </a:rPr>
-              <a:t>AI writes, code designs</a:t>
-            </a:r>
-            <a:endParaRPr lang="en-US" sz="1800" dirty="0"/>
-          </a:p>
-        </p:txBody>
-      </p:sp>
-      <p:sp>
-        <p:nvSpPr>
-          <p:cNvPr id="7" name="Text 4"/>
-          <p:cNvSpPr txBox="1"/>
-          <p:nvPr/>
-        </p:nvSpPr>
-        <p:spPr>
-          <a:xfrm>
-            <a:off x="731520" y="3017520"/>
-            <a:ext cx="2103120" cy="1325880"/>
-          </a:xfrm>
-          <a:prstGeom prst="rect">
-            <a:avLst/>
-          </a:prstGeom>
-          <a:noFill/>
-          <a:ln/>
-        </p:spPr>
-        <p:txBody>
-          <a:bodyPr wrap="square" lIns="0" tIns="0" rIns="0" bIns="0" rtlCol="0" anchor="t"/>
-          <a:lstStyle/>
-          <a:p>
-            <a:pPr marL="0" indent="0">
-              <a:buNone/>
-            </a:pPr>
-            <a:r>
-              <a:rPr lang="en-US" sz="1250" dirty="0">
-                <a:solidFill>
-                  <a:srgbClr val="5B6480"/>
-                </a:solidFill>
-                <a:latin typeface="Calibri" pitchFamily="34" charset="0"/>
-                <a:ea typeface="Calibri" pitchFamily="34" charset="-122"/>
-                <a:cs typeface="Calibri" pitchFamily="34" charset="-120"/>
-              </a:rPr>
-              <a:t>The AI only produces structured content. Templates render every word, so text is always correct and the result looks designed.</a:t>
-            </a:r>
-            <a:endParaRPr lang="en-US" sz="1250" dirty="0"/>
-          </a:p>
-        </p:txBody>
-      </p:sp>
-      <p:sp>
-        <p:nvSpPr>
-          <p:cNvPr id="8" name="Shape 5"/>
-          <p:cNvSpPr/>
-          <p:nvPr/>
-        </p:nvSpPr>
-        <p:spPr>
-          <a:xfrm>
-            <a:off x="3291840" y="1188720"/>
-            <a:ext cx="2606040" cy="2926080"/>
-          </a:xfrm>
-          <a:prstGeom prst="roundRect">
-            <a:avLst>
-              <a:gd name="adj" fmla="val 4211"/>
-            </a:avLst>
-          </a:prstGeom>
-          <a:solidFill>
-            <a:srgbClr val="EAF1FF"/>
-          </a:solidFill>
-          <a:ln w="12700">
-            <a:solidFill>
-              <a:srgbClr val="EAF1FF"/>
-            </a:solidFill>
-            <a:prstDash val="solid"/>
-          </a:ln>
-        </p:spPr>
-      </p:sp>
-      <p:sp>
-        <p:nvSpPr>
-          <p:cNvPr id="9" name="Shape 6"/>
-          <p:cNvSpPr/>
-          <p:nvPr/>
-        </p:nvSpPr>
-        <p:spPr>
-          <a:xfrm>
-            <a:off x="3566160" y="1463040"/>
-            <a:ext cx="731520" cy="731520"/>
-          </a:xfrm>
-          <a:prstGeom prst="ellipse">
-            <a:avLst/>
-          </a:prstGeom>
-          <a:solidFill>
-            <a:srgbClr val="1446D6"/>
-          </a:solidFill>
-          <a:ln w="12700">
-            <a:solidFill>
-              <a:srgbClr val="1446D6"/>
-            </a:solidFill>
-            <a:prstDash val="solid"/>
-          </a:ln>
-        </p:spPr>
-      </p:sp>
-      <p:pic>
-        <p:nvPicPr>
-          <p:cNvPr id="10" name="Image 1" descr="preencoded.png"/>
-          <p:cNvPicPr>
-            <a:picLocks noChangeAspect="1"/>
-          </p:cNvPicPr>
-          <p:nvPr/>
-        </p:nvPicPr>
-        <p:blipFill>
-          <a:blip r:embed="rId4"/>
-          <a:stretch>
-            <a:fillRect/>
-          </a:stretch>
-        </p:blipFill>
-        <p:spPr>
-          <a:xfrm>
-            <a:off x="3749040" y="1645920"/>
-            <a:ext cx="365760" cy="365760"/>
-          </a:xfrm>
-          <a:prstGeom prst="rect">
-            <a:avLst/>
-          </a:prstGeom>
-        </p:spPr>
-      </p:pic>
-      <p:sp>
-        <p:nvSpPr>
-          <p:cNvPr id="11" name="Text 7"/>
-          <p:cNvSpPr txBox="1"/>
-          <p:nvPr/>
-        </p:nvSpPr>
-        <p:spPr>
-          <a:xfrm>
-            <a:off x="3566160" y="2377440"/>
-            <a:ext cx="2103120" cy="640080"/>
-          </a:xfrm>
-          <a:prstGeom prst="rect">
-            <a:avLst/>
-          </a:prstGeom>
-          <a:noFill/>
-          <a:ln/>
-        </p:spPr>
-        <p:txBody>
-          <a:bodyPr wrap="square" lIns="0" tIns="0" rIns="0" bIns="0" rtlCol="0" anchor="t"/>
-          <a:lstStyle/>
-          <a:p>
-            <a:pPr marL="0" indent="0">
-              <a:buNone/>
-            </a:pPr>
-            <a:r>
-              <a:rPr lang="en-US" sz="1800" b="1" dirty="0">
-                <a:solidFill>
-                  <a:srgbClr val="0F1B3D"/>
-                </a:solidFill>
-                <a:latin typeface="Calibri" pitchFamily="34" charset="0"/>
-                <a:ea typeface="Calibri" pitchFamily="34" charset="-122"/>
-                <a:cs typeface="Calibri" pitchFamily="34" charset="-120"/>
-              </a:rPr>
-              <a:t>Real footage over AI video</a:t>
-            </a:r>
-            <a:endParaRPr lang="en-US" sz="1800" dirty="0"/>
-          </a:p>
-        </p:txBody>
-      </p:sp>
-      <p:sp>
-        <p:nvSpPr>
-          <p:cNvPr id="12" name="Text 8"/>
-          <p:cNvSpPr txBox="1"/>
-          <p:nvPr/>
-        </p:nvSpPr>
-        <p:spPr>
-          <a:xfrm>
-            <a:off x="3566160" y="3017520"/>
-            <a:ext cx="2103120" cy="1325880"/>
-          </a:xfrm>
-          <a:prstGeom prst="rect">
-            <a:avLst/>
-          </a:prstGeom>
-          <a:noFill/>
-          <a:ln/>
-        </p:spPr>
-        <p:txBody>
-          <a:bodyPr wrap="square" lIns="0" tIns="0" rIns="0" bIns="0" rtlCol="0" anchor="t"/>
-          <a:lstStyle/>
-          <a:p>
-            <a:pPr marL="0" indent="0">
-              <a:buNone/>
-            </a:pPr>
-            <a:r>
-              <a:rPr lang="en-US" sz="1250" dirty="0">
-                <a:solidFill>
-                  <a:srgbClr val="5B6480"/>
-                </a:solidFill>
-                <a:latin typeface="Calibri" pitchFamily="34" charset="0"/>
-                <a:ea typeface="Calibri" pitchFamily="34" charset="-122"/>
-                <a:cs typeface="Calibri" pitchFamily="34" charset="-120"/>
-              </a:rPr>
-              <a:t>We tested Google Veo: impressive, but hundreds of times more expensive and quota-limited. Veo stays available behind one setting.</a:t>
-            </a:r>
-            <a:endParaRPr lang="en-US" sz="1250" dirty="0"/>
-          </a:p>
-        </p:txBody>
-      </p:sp>
-      <p:sp>
-        <p:nvSpPr>
-          <p:cNvPr id="13" name="Shape 9"/>
-          <p:cNvSpPr/>
-          <p:nvPr/>
-        </p:nvSpPr>
-        <p:spPr>
-          <a:xfrm>
-            <a:off x="6126480" y="1188720"/>
-            <a:ext cx="2606040" cy="2926080"/>
-          </a:xfrm>
-          <a:prstGeom prst="roundRect">
-            <a:avLst>
-              <a:gd name="adj" fmla="val 4211"/>
-            </a:avLst>
-          </a:prstGeom>
-          <a:solidFill>
-            <a:srgbClr val="EAF1FF"/>
-          </a:solidFill>
-          <a:ln w="12700">
-            <a:solidFill>
-              <a:srgbClr val="EAF1FF"/>
-            </a:solidFill>
-            <a:prstDash val="solid"/>
-          </a:ln>
-        </p:spPr>
-      </p:sp>
-      <p:sp>
-        <p:nvSpPr>
-          <p:cNvPr id="14" name="Shape 10"/>
-          <p:cNvSpPr/>
-          <p:nvPr/>
-        </p:nvSpPr>
-        <p:spPr>
-          <a:xfrm>
-            <a:off x="6400800" y="1463040"/>
-            <a:ext cx="731520" cy="731520"/>
-          </a:xfrm>
-          <a:prstGeom prst="ellipse">
-            <a:avLst/>
-          </a:prstGeom>
-          <a:solidFill>
-            <a:srgbClr val="1446D6"/>
-          </a:solidFill>
-          <a:ln w="12700">
-            <a:solidFill>
-              <a:srgbClr val="1446D6"/>
-            </a:solidFill>
-            <a:prstDash val="solid"/>
-          </a:ln>
-        </p:spPr>
-      </p:sp>
-      <p:pic>
-        <p:nvPicPr>
-          <p:cNvPr id="15" name="Image 2" descr="preencoded.png"/>
-          <p:cNvPicPr>
-            <a:picLocks noChangeAspect="1"/>
-          </p:cNvPicPr>
-          <p:nvPr/>
-        </p:nvPicPr>
-        <p:blipFill>
-          <a:blip r:embed="rId5"/>
-          <a:stretch>
-            <a:fillRect/>
-          </a:stretch>
-        </p:blipFill>
-        <p:spPr>
-          <a:xfrm>
-            <a:off x="6583680" y="1645920"/>
-            <a:ext cx="365760" cy="365760"/>
-          </a:xfrm>
-          <a:prstGeom prst="rect">
-            <a:avLst/>
-          </a:prstGeom>
-        </p:spPr>
-      </p:pic>
-      <p:sp>
-        <p:nvSpPr>
-          <p:cNvPr id="16" name="Text 11"/>
-          <p:cNvSpPr txBox="1"/>
-          <p:nvPr/>
-        </p:nvSpPr>
-        <p:spPr>
-          <a:xfrm>
-            <a:off x="6400800" y="2377440"/>
-            <a:ext cx="2103120" cy="640080"/>
-          </a:xfrm>
-          <a:prstGeom prst="rect">
-            <a:avLst/>
-          </a:prstGeom>
-          <a:noFill/>
-          <a:ln/>
-        </p:spPr>
-        <p:txBody>
-          <a:bodyPr wrap="square" lIns="0" tIns="0" rIns="0" bIns="0" rtlCol="0" anchor="t"/>
-          <a:lstStyle/>
-          <a:p>
-            <a:pPr marL="0" indent="0">
-              <a:buNone/>
-            </a:pPr>
-            <a:r>
-              <a:rPr lang="en-US" sz="1800" b="1" dirty="0">
-                <a:solidFill>
-                  <a:srgbClr val="0F1B3D"/>
-                </a:solidFill>
-                <a:latin typeface="Calibri" pitchFamily="34" charset="0"/>
-                <a:ea typeface="Calibri" pitchFamily="34" charset="-122"/>
-                <a:cs typeface="Calibri" pitchFamily="34" charset="-120"/>
-              </a:rPr>
-              <a:t>A fallback for every step</a:t>
-            </a:r>
-            <a:endParaRPr lang="en-US" sz="1800" dirty="0"/>
-          </a:p>
-        </p:txBody>
-      </p:sp>
-      <p:sp>
-        <p:nvSpPr>
-          <p:cNvPr id="17" name="Text 12"/>
-          <p:cNvSpPr txBox="1"/>
-          <p:nvPr/>
-        </p:nvSpPr>
-        <p:spPr>
-          <a:xfrm>
-            <a:off x="6400800" y="3017520"/>
-            <a:ext cx="2103120" cy="1325880"/>
-          </a:xfrm>
-          <a:prstGeom prst="rect">
-            <a:avLst/>
-          </a:prstGeom>
-          <a:noFill/>
-          <a:ln/>
-        </p:spPr>
-        <p:txBody>
-          <a:bodyPr wrap="square" lIns="0" tIns="0" rIns="0" bIns="0" rtlCol="0" anchor="t"/>
-          <a:lstStyle/>
-          <a:p>
-            <a:pPr marL="0" indent="0">
-              <a:buNone/>
-            </a:pPr>
-            <a:r>
-              <a:rPr lang="en-US" sz="1250" dirty="0">
-                <a:solidFill>
-                  <a:srgbClr val="5B6480"/>
-                </a:solidFill>
-                <a:latin typeface="Calibri" pitchFamily="34" charset="0"/>
-                <a:ea typeface="Calibri" pitchFamily="34" charset="-122"/>
-                <a:cs typeface="Calibri" pitchFamily="34" charset="-120"/>
-              </a:rPr>
-              <a:t>Voice falls back to free Microsoft voices, the renderer to a simpler engine. Running out of quota still produces a video.</a:t>
-            </a:r>
-            <a:endParaRPr lang="en-US" sz="1250" dirty="0"/>
-          </a:p>
-        </p:txBody>
-      </p:sp>
-    </p:spTree>
-  </p:cSld>
-  <p:clrMapOvr>
-    <a:masterClrMapping/>
-  </p:clrMapOvr>
-</p:sld>
-</file>
-
-<file path=ppt/slides/slide7.xml><?xml version="1.0" encoding="utf-8"?>
-<p:sld xmlns:a="http://schemas.openxmlformats.org/drawingml/2006/main" xmlns:r="http://schemas.openxmlformats.org/officeDocument/2006/relationships" xmlns:p="http://schemas.openxmlformats.org/presentationml/2006/main">
-  <p:cSld name="Slide 8">
-    <p:bg>
-      <p:bgPr>
-        <a:solidFill>
-          <a:srgbClr val="FFFFFF"/>
-        </a:solidFill>
-        <a:effectLst/>
-      </p:bgPr>
-    </p:bg>
-    <p:spTree>
-      <p:nvGrpSpPr>
-        <p:cNvPr id="1" name=""/>
-        <p:cNvGrpSpPr/>
-        <p:nvPr/>
-      </p:nvGrpSpPr>
-      <p:grpSpPr>
-        <a:xfrm>
-          <a:off x="0" y="0"/>
-          <a:ext cx="0" cy="0"/>
-          <a:chOff x="0" y="0"/>
-          <a:chExt cx="0" cy="0"/>
-        </a:xfrm>
-      </p:grpSpPr>
-      <p:sp>
-        <p:nvSpPr>
-          <p:cNvPr id="2" name="Text 0"/>
-          <p:cNvSpPr txBox="1"/>
-          <p:nvPr/>
-        </p:nvSpPr>
-        <p:spPr>
-          <a:xfrm>
-            <a:off x="457200" y="320040"/>
-            <a:ext cx="8229600" cy="640080"/>
-          </a:xfrm>
-          <a:prstGeom prst="rect">
-            <a:avLst/>
-          </a:prstGeom>
-          <a:noFill/>
-          <a:ln/>
-        </p:spPr>
-        <p:txBody>
-          <a:bodyPr wrap="square" lIns="0" tIns="0" rIns="0" bIns="0" rtlCol="0" anchor="ctr"/>
-          <a:lstStyle/>
-          <a:p>
-            <a:pPr marL="0" indent="0">
-              <a:buNone/>
-            </a:pPr>
-            <a:r>
-              <a:rPr lang="en-US" sz="3200" b="1" dirty="0">
-                <a:solidFill>
-                  <a:srgbClr val="0F1B3D"/>
-                </a:solidFill>
-                <a:latin typeface="Calibri" pitchFamily="34" charset="0"/>
-                <a:ea typeface="Calibri" pitchFamily="34" charset="-122"/>
-                <a:cs typeface="Calibri" pitchFamily="34" charset="-120"/>
-              </a:rPr>
-              <a:t>Current limitations</a:t>
-            </a:r>
-            <a:endParaRPr lang="en-US" sz="3200" dirty="0"/>
-          </a:p>
-        </p:txBody>
-      </p:sp>
-      <p:sp>
-        <p:nvSpPr>
-          <p:cNvPr id="3" name="Shape 1"/>
-          <p:cNvSpPr/>
-          <p:nvPr/>
-        </p:nvSpPr>
-        <p:spPr>
-          <a:xfrm>
-            <a:off x="457200" y="1097280"/>
-            <a:ext cx="4023360" cy="1600200"/>
-          </a:xfrm>
-          <a:prstGeom prst="roundRect">
-            <a:avLst>
-              <a:gd name="adj" fmla="val 6857"/>
-            </a:avLst>
-          </a:prstGeom>
-          <a:solidFill>
-            <a:srgbClr val="FFFFFF"/>
-          </a:solidFill>
-          <a:ln w="12700">
-            <a:solidFill>
-              <a:srgbClr val="C9D6F5"/>
-            </a:solidFill>
-            <a:prstDash val="solid"/>
-          </a:ln>
-        </p:spPr>
-      </p:sp>
-      <p:sp>
-        <p:nvSpPr>
-          <p:cNvPr id="4" name="Shape 2"/>
-          <p:cNvSpPr/>
-          <p:nvPr/>
-        </p:nvSpPr>
-        <p:spPr>
-          <a:xfrm>
-            <a:off x="685800" y="1325880"/>
-            <a:ext cx="548640" cy="548640"/>
-          </a:xfrm>
-          <a:prstGeom prst="ellipse">
-            <a:avLst/>
-          </a:prstGeom>
-          <a:solidFill>
-            <a:srgbClr val="EAF1FF"/>
-          </a:solidFill>
-          <a:ln w="12700">
-            <a:solidFill>
-              <a:srgbClr val="EAF1FF"/>
-            </a:solidFill>
-            <a:prstDash val="solid"/>
-          </a:ln>
-        </p:spPr>
-      </p:sp>
-      <p:pic>
-        <p:nvPicPr>
-          <p:cNvPr id="5" name="Image 0" descr="preencoded.png"/>
-          <p:cNvPicPr>
-            <a:picLocks noChangeAspect="1"/>
-          </p:cNvPicPr>
-          <p:nvPr/>
-        </p:nvPicPr>
-        <p:blipFill>
-          <a:blip r:embed="rId3"/>
-          <a:stretch>
-            <a:fillRect/>
-          </a:stretch>
-        </p:blipFill>
-        <p:spPr>
-          <a:xfrm>
-            <a:off x="822960" y="1463040"/>
-            <a:ext cx="274320" cy="274320"/>
-          </a:xfrm>
-          <a:prstGeom prst="rect">
-            <a:avLst/>
-          </a:prstGeom>
-        </p:spPr>
-      </p:pic>
-      <p:sp>
-        <p:nvSpPr>
-          <p:cNvPr id="6" name="Text 3"/>
-          <p:cNvSpPr txBox="1"/>
-          <p:nvPr/>
-        </p:nvSpPr>
-        <p:spPr>
-          <a:xfrm>
-            <a:off x="1417320" y="1298448"/>
-            <a:ext cx="2926080" cy="347472"/>
-          </a:xfrm>
-          <a:prstGeom prst="rect">
-            <a:avLst/>
-          </a:prstGeom>
-          <a:noFill/>
-          <a:ln/>
-        </p:spPr>
-        <p:txBody>
-          <a:bodyPr wrap="square" lIns="0" tIns="0" rIns="0" bIns="0" rtlCol="0" anchor="ctr"/>
           <a:lstStyle/>
           <a:p>
             <a:pPr marL="0" indent="0">
@@ -4009,8 +4329,8 @@
         </p:nvSpPr>
         <p:spPr>
           <a:xfrm>
-            <a:off x="1417320" y="1645920"/>
-            <a:ext cx="2926080" cy="457200"/>
+            <a:off x="1508760" y="1645920"/>
+            <a:ext cx="2834640" cy="457200"/>
           </a:xfrm>
           <a:prstGeom prst="rect">
             <a:avLst/>
@@ -4048,8 +4368,8 @@
         </p:nvSpPr>
         <p:spPr>
           <a:xfrm>
-            <a:off x="1417320" y="2148840"/>
-            <a:ext cx="2926080" cy="320040"/>
+            <a:off x="1508760" y="2167128"/>
+            <a:ext cx="2834640" cy="320040"/>
           </a:xfrm>
           <a:prstGeom prst="rect">
             <a:avLst/>
@@ -4058,7 +4378,7 @@
           <a:ln/>
         </p:spPr>
         <p:txBody>
-          <a:bodyPr wrap="square" lIns="0" tIns="0" rIns="0" bIns="0" rtlCol="0" anchor="ctr"/>
+          <a:bodyPr wrap="square" lIns="0" tIns="0" rIns="0" bIns="0" rtlCol="0" anchor="t"/>
           <a:lstStyle/>
           <a:p>
             <a:pPr marL="0" indent="0">
@@ -4098,12 +4418,19 @@
           <a:solidFill>
             <a:srgbClr val="FFFFFF"/>
           </a:solidFill>
-          <a:ln w="12700">
+          <a:ln w="9525">
             <a:solidFill>
-              <a:srgbClr val="C9D6F5"/>
+              <a:srgbClr val="DCE3F2"/>
             </a:solidFill>
             <a:prstDash val="solid"/>
           </a:ln>
+          <a:effectLst>
+            <a:outerShdw blurRad="127000" dist="38100" dir="5400000" algn="bl" rotWithShape="0">
+              <a:srgbClr val="0F1B3D">
+                <a:alpha val="12000"/>
+              </a:srgbClr>
+            </a:outerShdw>
+          </a:effectLst>
         </p:spPr>
       </p:sp>
       <p:sp>
@@ -4115,25 +4442,34 @@
         <p:spPr>
           <a:xfrm>
             <a:off x="4892040" y="1325880"/>
-            <a:ext cx="548640" cy="548640"/>
-          </a:xfrm>
-          <a:prstGeom prst="ellipse">
-            <a:avLst/>
+            <a:ext cx="640080" cy="640080"/>
+          </a:xfrm>
+          <a:prstGeom prst="roundRect">
+            <a:avLst>
+              <a:gd name="adj" fmla="val 22000"/>
+            </a:avLst>
           </a:prstGeom>
           <a:solidFill>
-            <a:srgbClr val="EAF1FF"/>
+            <a:srgbClr val="FFFFFF"/>
           </a:solidFill>
           <a:ln w="12700">
             <a:solidFill>
-              <a:srgbClr val="EAF1FF"/>
+              <a:srgbClr val="FFFFFF"/>
             </a:solidFill>
             <a:prstDash val="solid"/>
           </a:ln>
+          <a:effectLst>
+            <a:outerShdw blurRad="127000" dist="38100" dir="5400000" algn="bl" rotWithShape="0">
+              <a:srgbClr val="0F1B3D">
+                <a:alpha val="12000"/>
+              </a:srgbClr>
+            </a:outerShdw>
+          </a:effectLst>
         </p:spPr>
       </p:sp>
       <p:pic>
         <p:nvPicPr>
-          <p:cNvPr id="11" name="Image 1" descr="preencoded.png"/>
+          <p:cNvPr id="11" name="Image 1" descr="C:\Users\Admin\AppData\Local\Temp\claude\d--SmartTutor\5ff2c210-ed39-47c1-9187-8611ef6ccd50\scratchpad\deck\emoji\busts.png"/>
           <p:cNvPicPr>
             <a:picLocks noChangeAspect="1"/>
           </p:cNvPicPr>
@@ -4147,8 +4483,8 @@
         </p:blipFill>
         <p:spPr>
           <a:xfrm>
-            <a:off x="5029200" y="1463040"/>
-            <a:ext cx="274320" cy="274320"/>
+            <a:off x="4994453" y="1428293"/>
+            <a:ext cx="435254" cy="435254"/>
           </a:xfrm>
           <a:prstGeom prst="rect">
             <a:avLst/>
@@ -4163,8 +4499,8 @@
         </p:nvSpPr>
         <p:spPr>
           <a:xfrm>
-            <a:off x="5623560" y="1298448"/>
-            <a:ext cx="2926080" cy="347472"/>
+            <a:off x="5715000" y="1298448"/>
+            <a:ext cx="2834640" cy="347472"/>
           </a:xfrm>
           <a:prstGeom prst="rect">
             <a:avLst/>
@@ -4173,7 +4509,7 @@
           <a:ln/>
         </p:spPr>
         <p:txBody>
-          <a:bodyPr wrap="square" lIns="0" tIns="0" rIns="0" bIns="0" rtlCol="0" anchor="ctr"/>
+          <a:bodyPr wrap="square" lIns="0" tIns="0" rIns="0" bIns="0" rtlCol="0" anchor="t"/>
           <a:lstStyle/>
           <a:p>
             <a:pPr marL="0" indent="0">
@@ -4202,8 +4538,8 @@
         </p:nvSpPr>
         <p:spPr>
           <a:xfrm>
-            <a:off x="5623560" y="1645920"/>
-            <a:ext cx="2926080" cy="457200"/>
+            <a:off x="5715000" y="1645920"/>
+            <a:ext cx="2834640" cy="457200"/>
           </a:xfrm>
           <a:prstGeom prst="rect">
             <a:avLst/>
@@ -4241,8 +4577,8 @@
         </p:nvSpPr>
         <p:spPr>
           <a:xfrm>
-            <a:off x="5623560" y="2148840"/>
-            <a:ext cx="2926080" cy="320040"/>
+            <a:off x="5715000" y="2167128"/>
+            <a:ext cx="2834640" cy="320040"/>
           </a:xfrm>
           <a:prstGeom prst="rect">
             <a:avLst/>
@@ -4251,7 +4587,7 @@
           <a:ln/>
         </p:spPr>
         <p:txBody>
-          <a:bodyPr wrap="square" lIns="0" tIns="0" rIns="0" bIns="0" rtlCol="0" anchor="ctr"/>
+          <a:bodyPr wrap="square" lIns="0" tIns="0" rIns="0" bIns="0" rtlCol="0" anchor="t"/>
           <a:lstStyle/>
           <a:p>
             <a:pPr marL="0" indent="0">
@@ -4291,12 +4627,19 @@
           <a:solidFill>
             <a:srgbClr val="FFFFFF"/>
           </a:solidFill>
-          <a:ln w="12700">
+          <a:ln w="9525">
             <a:solidFill>
-              <a:srgbClr val="C9D6F5"/>
+              <a:srgbClr val="DCE3F2"/>
             </a:solidFill>
             <a:prstDash val="solid"/>
           </a:ln>
+          <a:effectLst>
+            <a:outerShdw blurRad="127000" dist="38100" dir="5400000" algn="bl" rotWithShape="0">
+              <a:srgbClr val="0F1B3D">
+                <a:alpha val="12000"/>
+              </a:srgbClr>
+            </a:outerShdw>
+          </a:effectLst>
         </p:spPr>
       </p:sp>
       <p:sp>
@@ -4308,25 +4651,34 @@
         <p:spPr>
           <a:xfrm>
             <a:off x="685800" y="3108960"/>
-            <a:ext cx="548640" cy="548640"/>
-          </a:xfrm>
-          <a:prstGeom prst="ellipse">
-            <a:avLst/>
+            <a:ext cx="640080" cy="640080"/>
+          </a:xfrm>
+          <a:prstGeom prst="roundRect">
+            <a:avLst>
+              <a:gd name="adj" fmla="val 22000"/>
+            </a:avLst>
           </a:prstGeom>
           <a:solidFill>
-            <a:srgbClr val="EAF1FF"/>
+            <a:srgbClr val="FFFFFF"/>
           </a:solidFill>
           <a:ln w="12700">
             <a:solidFill>
-              <a:srgbClr val="EAF1FF"/>
+              <a:srgbClr val="FFFFFF"/>
             </a:solidFill>
             <a:prstDash val="solid"/>
           </a:ln>
+          <a:effectLst>
+            <a:outerShdw blurRad="127000" dist="38100" dir="5400000" algn="bl" rotWithShape="0">
+              <a:srgbClr val="0F1B3D">
+                <a:alpha val="12000"/>
+              </a:srgbClr>
+            </a:outerShdw>
+          </a:effectLst>
         </p:spPr>
       </p:sp>
       <p:pic>
         <p:nvPicPr>
-          <p:cNvPr id="17" name="Image 2" descr="preencoded.png"/>
+          <p:cNvPr id="17" name="Image 2" descr="C:\Users\Admin\AppData\Local\Temp\claude\d--SmartTutor\5ff2c210-ed39-47c1-9187-8611ef6ccd50\scratchpad\deck\emoji\hourglass.png"/>
           <p:cNvPicPr>
             <a:picLocks noChangeAspect="1"/>
           </p:cNvPicPr>
@@ -4340,8 +4692,8 @@
         </p:blipFill>
         <p:spPr>
           <a:xfrm>
-            <a:off x="822960" y="3246120"/>
-            <a:ext cx="274320" cy="274320"/>
+            <a:off x="788213" y="3211373"/>
+            <a:ext cx="435254" cy="435254"/>
           </a:xfrm>
           <a:prstGeom prst="rect">
             <a:avLst/>
@@ -4356,8 +4708,8 @@
         </p:nvSpPr>
         <p:spPr>
           <a:xfrm>
-            <a:off x="1417320" y="3081528"/>
-            <a:ext cx="2926080" cy="347472"/>
+            <a:off x="1508760" y="3081528"/>
+            <a:ext cx="2834640" cy="347472"/>
           </a:xfrm>
           <a:prstGeom prst="rect">
             <a:avLst/>
@@ -4366,7 +4718,7 @@
           <a:ln/>
         </p:spPr>
         <p:txBody>
-          <a:bodyPr wrap="square" lIns="0" tIns="0" rIns="0" bIns="0" rtlCol="0" anchor="ctr"/>
+          <a:bodyPr wrap="square" lIns="0" tIns="0" rIns="0" bIns="0" rtlCol="0" anchor="t"/>
           <a:lstStyle/>
           <a:p>
             <a:pPr marL="0" indent="0">
@@ -4395,8 +4747,8 @@
         </p:nvSpPr>
         <p:spPr>
           <a:xfrm>
-            <a:off x="1417320" y="3429000"/>
-            <a:ext cx="2926080" cy="457200"/>
+            <a:off x="1508760" y="3429000"/>
+            <a:ext cx="2834640" cy="457200"/>
           </a:xfrm>
           <a:prstGeom prst="rect">
             <a:avLst/>
@@ -4434,8 +4786,8 @@
         </p:nvSpPr>
         <p:spPr>
           <a:xfrm>
-            <a:off x="1417320" y="3931920"/>
-            <a:ext cx="2926080" cy="320040"/>
+            <a:off x="1508760" y="3950208"/>
+            <a:ext cx="2834640" cy="320040"/>
           </a:xfrm>
           <a:prstGeom prst="rect">
             <a:avLst/>
@@ -4444,7 +4796,7 @@
           <a:ln/>
         </p:spPr>
         <p:txBody>
-          <a:bodyPr wrap="square" lIns="0" tIns="0" rIns="0" bIns="0" rtlCol="0" anchor="ctr"/>
+          <a:bodyPr wrap="square" lIns="0" tIns="0" rIns="0" bIns="0" rtlCol="0" anchor="t"/>
           <a:lstStyle/>
           <a:p>
             <a:pPr marL="0" indent="0">
@@ -4484,12 +4836,19 @@
           <a:solidFill>
             <a:srgbClr val="FFFFFF"/>
           </a:solidFill>
-          <a:ln w="12700">
+          <a:ln w="9525">
             <a:solidFill>
-              <a:srgbClr val="C9D6F5"/>
+              <a:srgbClr val="DCE3F2"/>
             </a:solidFill>
             <a:prstDash val="solid"/>
           </a:ln>
+          <a:effectLst>
+            <a:outerShdw blurRad="127000" dist="38100" dir="5400000" algn="bl" rotWithShape="0">
+              <a:srgbClr val="0F1B3D">
+                <a:alpha val="12000"/>
+              </a:srgbClr>
+            </a:outerShdw>
+          </a:effectLst>
         </p:spPr>
       </p:sp>
       <p:sp>
@@ -4501,25 +4860,34 @@
         <p:spPr>
           <a:xfrm>
             <a:off x="4892040" y="3108960"/>
-            <a:ext cx="548640" cy="548640"/>
-          </a:xfrm>
-          <a:prstGeom prst="ellipse">
-            <a:avLst/>
+            <a:ext cx="640080" cy="640080"/>
+          </a:xfrm>
+          <a:prstGeom prst="roundRect">
+            <a:avLst>
+              <a:gd name="adj" fmla="val 22000"/>
+            </a:avLst>
           </a:prstGeom>
           <a:solidFill>
-            <a:srgbClr val="EAF1FF"/>
+            <a:srgbClr val="FFFFFF"/>
           </a:solidFill>
           <a:ln w="12700">
             <a:solidFill>
-              <a:srgbClr val="EAF1FF"/>
+              <a:srgbClr val="FFFFFF"/>
             </a:solidFill>
             <a:prstDash val="solid"/>
           </a:ln>
+          <a:effectLst>
+            <a:outerShdw blurRad="127000" dist="38100" dir="5400000" algn="bl" rotWithShape="0">
+              <a:srgbClr val="0F1B3D">
+                <a:alpha val="12000"/>
+              </a:srgbClr>
+            </a:outerShdw>
+          </a:effectLst>
         </p:spPr>
       </p:sp>
       <p:pic>
         <p:nvPicPr>
-          <p:cNvPr id="23" name="Image 3" descr="preencoded.png"/>
+          <p:cNvPr id="23" name="Image 3" descr="C:\Users\Admin\AppData\Local\Temp\claude\d--SmartTutor\5ff2c210-ed39-47c1-9187-8611ef6ccd50\scratchpad\deck\emoji\lock.png"/>
           <p:cNvPicPr>
             <a:picLocks noChangeAspect="1"/>
           </p:cNvPicPr>
@@ -4533,8 +4901,8 @@
         </p:blipFill>
         <p:spPr>
           <a:xfrm>
-            <a:off x="5029200" y="3246120"/>
-            <a:ext cx="274320" cy="274320"/>
+            <a:off x="4994453" y="3211373"/>
+            <a:ext cx="435254" cy="435254"/>
           </a:xfrm>
           <a:prstGeom prst="rect">
             <a:avLst/>
@@ -4549,8 +4917,8 @@
         </p:nvSpPr>
         <p:spPr>
           <a:xfrm>
-            <a:off x="5623560" y="3081528"/>
-            <a:ext cx="2926080" cy="347472"/>
+            <a:off x="5715000" y="3081528"/>
+            <a:ext cx="2834640" cy="347472"/>
           </a:xfrm>
           <a:prstGeom prst="rect">
             <a:avLst/>
@@ -4559,7 +4927,7 @@
           <a:ln/>
         </p:spPr>
         <p:txBody>
-          <a:bodyPr wrap="square" lIns="0" tIns="0" rIns="0" bIns="0" rtlCol="0" anchor="ctr"/>
+          <a:bodyPr wrap="square" lIns="0" tIns="0" rIns="0" bIns="0" rtlCol="0" anchor="t"/>
           <a:lstStyle/>
           <a:p>
             <a:pPr marL="0" indent="0">
@@ -4588,8 +4956,8 @@
         </p:nvSpPr>
         <p:spPr>
           <a:xfrm>
-            <a:off x="5623560" y="3429000"/>
-            <a:ext cx="2926080" cy="457200"/>
+            <a:off x="5715000" y="3429000"/>
+            <a:ext cx="2834640" cy="457200"/>
           </a:xfrm>
           <a:prstGeom prst="rect">
             <a:avLst/>
@@ -4627,8 +4995,8 @@
         </p:nvSpPr>
         <p:spPr>
           <a:xfrm>
-            <a:off x="5623560" y="3931920"/>
-            <a:ext cx="2926080" cy="320040"/>
+            <a:off x="5715000" y="3950208"/>
+            <a:ext cx="2834640" cy="320040"/>
           </a:xfrm>
           <a:prstGeom prst="rect">
             <a:avLst/>
@@ -4637,7 +5005,7 @@
           <a:ln/>
         </p:spPr>
         <p:txBody>
-          <a:bodyPr wrap="square" lIns="0" tIns="0" rIns="0" bIns="0" rtlCol="0" anchor="ctr"/>
+          <a:bodyPr wrap="square" lIns="0" tIns="0" rIns="0" bIns="0" rtlCol="0" anchor="t"/>
           <a:lstStyle/>
           <a:p>
             <a:pPr marL="0" indent="0">
@@ -4712,21 +5080,19 @@
           <a:bodyPr wrap="square" lIns="0" tIns="0" rIns="0" bIns="0" rtlCol="0" anchor="ctr"/>
           <a:lstStyle/>
           <a:p>
-            <a:pPr marL="0" indent="0">
-              <a:buNone/>
-            </a:pPr>
-            <a:r>
-              <a:rPr lang="en-US" sz="3200" b="1" dirty="0">
+            <a:r>
+              <a:rPr lang="en-US" sz="2800" b="1" i="1" dirty="0">
                 <a:solidFill>
-                  <a:srgbClr val="FFFFFF"/>
+                  <a:schemeClr val="bg1"/>
                 </a:solidFill>
-                <a:latin typeface="Calibri" pitchFamily="34" charset="0"/>
-                <a:ea typeface="Calibri" pitchFamily="34" charset="-122"/>
-                <a:cs typeface="Calibri" pitchFamily="34" charset="-120"/>
               </a:rPr>
-              <a:t>Roadmap</a:t>
-            </a:r>
-            <a:endParaRPr lang="en-US" sz="3200" dirty="0"/>
+              <a:t>Future improvements</a:t>
+            </a:r>
+            <a:endParaRPr lang="en-US" sz="2800" b="1" dirty="0">
+              <a:solidFill>
+                <a:schemeClr val="bg1"/>
+              </a:solidFill>
+            </a:endParaRPr>
           </a:p>
         </p:txBody>
       </p:sp>
@@ -4738,26 +5104,35 @@
         </p:nvSpPr>
         <p:spPr>
           <a:xfrm>
-            <a:off x="457200" y="1097280"/>
-            <a:ext cx="594360" cy="594360"/>
-          </a:xfrm>
-          <a:prstGeom prst="ellipse">
-            <a:avLst/>
+            <a:off x="457200" y="1143000"/>
+            <a:ext cx="731520" cy="731520"/>
+          </a:xfrm>
+          <a:prstGeom prst="roundRect">
+            <a:avLst>
+              <a:gd name="adj" fmla="val 22000"/>
+            </a:avLst>
           </a:prstGeom>
           <a:solidFill>
-            <a:srgbClr val="1446D6"/>
+            <a:srgbClr val="FFFFFF"/>
           </a:solidFill>
           <a:ln w="12700">
             <a:solidFill>
-              <a:srgbClr val="1446D6"/>
+              <a:srgbClr val="FFFFFF"/>
             </a:solidFill>
             <a:prstDash val="solid"/>
           </a:ln>
+          <a:effectLst>
+            <a:outerShdw blurRad="127000" dist="38100" dir="5400000" algn="bl" rotWithShape="0">
+              <a:srgbClr val="0F1B3D">
+                <a:alpha val="12000"/>
+              </a:srgbClr>
+            </a:outerShdw>
+          </a:effectLst>
         </p:spPr>
       </p:sp>
       <p:pic>
         <p:nvPicPr>
-          <p:cNvPr id="4" name="Image 0" descr="preencoded.png"/>
+          <p:cNvPr id="4" name="Image 0" descr="C:\Users\Admin\AppData\Local\Temp\claude\d--SmartTutor\5ff2c210-ed39-47c1-9187-8611ef6ccd50\scratchpad\deck\emoji\cloud.png"/>
           <p:cNvPicPr>
             <a:picLocks noChangeAspect="1"/>
           </p:cNvPicPr>
@@ -4771,8 +5146,8 @@
         </p:blipFill>
         <p:spPr>
           <a:xfrm>
-            <a:off x="605790" y="1245870"/>
-            <a:ext cx="297180" cy="297180"/>
+            <a:off x="574243" y="1260043"/>
+            <a:ext cx="497434" cy="497434"/>
           </a:xfrm>
           <a:prstGeom prst="rect">
             <a:avLst/>
@@ -4787,8 +5162,8 @@
         </p:nvSpPr>
         <p:spPr>
           <a:xfrm>
-            <a:off x="1188720" y="1078992"/>
-            <a:ext cx="3291840" cy="329184"/>
+            <a:off x="1371600" y="1197864"/>
+            <a:ext cx="3108960" cy="329184"/>
           </a:xfrm>
           <a:prstGeom prst="rect">
             <a:avLst/>
@@ -4797,7 +5172,7 @@
           <a:ln/>
         </p:spPr>
         <p:txBody>
-          <a:bodyPr wrap="square" lIns="0" tIns="0" rIns="0" bIns="0" rtlCol="0" anchor="ctr"/>
+          <a:bodyPr wrap="square" lIns="0" tIns="0" rIns="0" bIns="0" rtlCol="0" anchor="t"/>
           <a:lstStyle/>
           <a:p>
             <a:pPr marL="0" indent="0">
@@ -4826,8 +5201,8 @@
         </p:nvSpPr>
         <p:spPr>
           <a:xfrm>
-            <a:off x="1188720" y="1408176"/>
-            <a:ext cx="3291840" cy="292608"/>
+            <a:off x="1371600" y="1527048"/>
+            <a:ext cx="3108960" cy="292608"/>
           </a:xfrm>
           <a:prstGeom prst="rect">
             <a:avLst/>
@@ -4836,7 +5211,7 @@
           <a:ln/>
         </p:spPr>
         <p:txBody>
-          <a:bodyPr wrap="square" lIns="0" tIns="0" rIns="0" bIns="0" rtlCol="0" anchor="ctr"/>
+          <a:bodyPr wrap="square" lIns="0" tIns="0" rIns="0" bIns="0" rtlCol="0" anchor="t"/>
           <a:lstStyle/>
           <a:p>
             <a:pPr marL="0" indent="0">
@@ -4865,26 +5240,35 @@
         </p:nvSpPr>
         <p:spPr>
           <a:xfrm>
-            <a:off x="4663440" y="1097280"/>
-            <a:ext cx="594360" cy="594360"/>
-          </a:xfrm>
-          <a:prstGeom prst="ellipse">
-            <a:avLst/>
+            <a:off x="4663440" y="1143000"/>
+            <a:ext cx="731520" cy="731520"/>
+          </a:xfrm>
+          <a:prstGeom prst="roundRect">
+            <a:avLst>
+              <a:gd name="adj" fmla="val 22000"/>
+            </a:avLst>
           </a:prstGeom>
           <a:solidFill>
-            <a:srgbClr val="1446D6"/>
+            <a:srgbClr val="FFFFFF"/>
           </a:solidFill>
           <a:ln w="12700">
             <a:solidFill>
-              <a:srgbClr val="1446D6"/>
+              <a:srgbClr val="FFFFFF"/>
             </a:solidFill>
             <a:prstDash val="solid"/>
           </a:ln>
+          <a:effectLst>
+            <a:outerShdw blurRad="127000" dist="38100" dir="5400000" algn="bl" rotWithShape="0">
+              <a:srgbClr val="0F1B3D">
+                <a:alpha val="12000"/>
+              </a:srgbClr>
+            </a:outerShdw>
+          </a:effectLst>
         </p:spPr>
       </p:sp>
       <p:pic>
         <p:nvPicPr>
-          <p:cNvPr id="8" name="Image 1" descr="preencoded.png"/>
+          <p:cNvPr id="8" name="Image 1" descr="C:\Users\Admin\AppData\Local\Temp\claude\d--SmartTutor\5ff2c210-ed39-47c1-9187-8611ef6ccd50\scratchpad\deck\emoji\memo.png"/>
           <p:cNvPicPr>
             <a:picLocks noChangeAspect="1"/>
           </p:cNvPicPr>
@@ -4898,8 +5282,8 @@
         </p:blipFill>
         <p:spPr>
           <a:xfrm>
-            <a:off x="4812030" y="1245870"/>
-            <a:ext cx="297180" cy="297180"/>
+            <a:off x="4780483" y="1260043"/>
+            <a:ext cx="497434" cy="497434"/>
           </a:xfrm>
           <a:prstGeom prst="rect">
             <a:avLst/>
@@ -4914,8 +5298,8 @@
         </p:nvSpPr>
         <p:spPr>
           <a:xfrm>
-            <a:off x="5394960" y="1078992"/>
-            <a:ext cx="3291840" cy="329184"/>
+            <a:off x="5577840" y="1197864"/>
+            <a:ext cx="3108960" cy="329184"/>
           </a:xfrm>
           <a:prstGeom prst="rect">
             <a:avLst/>
@@ -4924,7 +5308,7 @@
           <a:ln/>
         </p:spPr>
         <p:txBody>
-          <a:bodyPr wrap="square" lIns="0" tIns="0" rIns="0" bIns="0" rtlCol="0" anchor="ctr"/>
+          <a:bodyPr wrap="square" lIns="0" tIns="0" rIns="0" bIns="0" rtlCol="0" anchor="t"/>
           <a:lstStyle/>
           <a:p>
             <a:pPr marL="0" indent="0">
@@ -4953,8 +5337,8 @@
         </p:nvSpPr>
         <p:spPr>
           <a:xfrm>
-            <a:off x="5394960" y="1408176"/>
-            <a:ext cx="3291840" cy="292608"/>
+            <a:off x="5577840" y="1527048"/>
+            <a:ext cx="3108960" cy="292608"/>
           </a:xfrm>
           <a:prstGeom prst="rect">
             <a:avLst/>
@@ -4963,7 +5347,7 @@
           <a:ln/>
         </p:spPr>
         <p:txBody>
-          <a:bodyPr wrap="square" lIns="0" tIns="0" rIns="0" bIns="0" rtlCol="0" anchor="ctr"/>
+          <a:bodyPr wrap="square" lIns="0" tIns="0" rIns="0" bIns="0" rtlCol="0" anchor="t"/>
           <a:lstStyle/>
           <a:p>
             <a:pPr marL="0" indent="0">
@@ -4992,26 +5376,35 @@
         </p:nvSpPr>
         <p:spPr>
           <a:xfrm>
-            <a:off x="457200" y="2103120"/>
-            <a:ext cx="594360" cy="594360"/>
-          </a:xfrm>
-          <a:prstGeom prst="ellipse">
-            <a:avLst/>
+            <a:off x="457200" y="2240280"/>
+            <a:ext cx="731520" cy="731520"/>
+          </a:xfrm>
+          <a:prstGeom prst="roundRect">
+            <a:avLst>
+              <a:gd name="adj" fmla="val 22000"/>
+            </a:avLst>
           </a:prstGeom>
           <a:solidFill>
-            <a:srgbClr val="1446D6"/>
+            <a:srgbClr val="FFFFFF"/>
           </a:solidFill>
           <a:ln w="12700">
             <a:solidFill>
-              <a:srgbClr val="1446D6"/>
+              <a:srgbClr val="FFFFFF"/>
             </a:solidFill>
             <a:prstDash val="solid"/>
           </a:ln>
+          <a:effectLst>
+            <a:outerShdw blurRad="127000" dist="38100" dir="5400000" algn="bl" rotWithShape="0">
+              <a:srgbClr val="0F1B3D">
+                <a:alpha val="12000"/>
+              </a:srgbClr>
+            </a:outerShdw>
+          </a:effectLst>
         </p:spPr>
       </p:sp>
       <p:pic>
         <p:nvPicPr>
-          <p:cNvPr id="12" name="Image 2" descr="preencoded.png"/>
+          <p:cNvPr id="12" name="Image 2" descr="C:\Users\Admin\AppData\Local\Temp\claude\d--SmartTutor\5ff2c210-ed39-47c1-9187-8611ef6ccd50\scratchpad\deck\emoji\cap.png"/>
           <p:cNvPicPr>
             <a:picLocks noChangeAspect="1"/>
           </p:cNvPicPr>
@@ -5025,8 +5418,8 @@
         </p:blipFill>
         <p:spPr>
           <a:xfrm>
-            <a:off x="605790" y="2251710"/>
-            <a:ext cx="297180" cy="297180"/>
+            <a:off x="574243" y="2357323"/>
+            <a:ext cx="497434" cy="497434"/>
           </a:xfrm>
           <a:prstGeom prst="rect">
             <a:avLst/>
@@ -5041,8 +5434,8 @@
         </p:nvSpPr>
         <p:spPr>
           <a:xfrm>
-            <a:off x="1188720" y="2084832"/>
-            <a:ext cx="3291840" cy="329184"/>
+            <a:off x="1371600" y="2295144"/>
+            <a:ext cx="3108960" cy="329184"/>
           </a:xfrm>
           <a:prstGeom prst="rect">
             <a:avLst/>
@@ -5051,7 +5444,7 @@
           <a:ln/>
         </p:spPr>
         <p:txBody>
-          <a:bodyPr wrap="square" lIns="0" tIns="0" rIns="0" bIns="0" rtlCol="0" anchor="ctr"/>
+          <a:bodyPr wrap="square" lIns="0" tIns="0" rIns="0" bIns="0" rtlCol="0" anchor="t"/>
           <a:lstStyle/>
           <a:p>
             <a:pPr marL="0" indent="0">
@@ -5080,8 +5473,8 @@
         </p:nvSpPr>
         <p:spPr>
           <a:xfrm>
-            <a:off x="1188720" y="2414016"/>
-            <a:ext cx="3291840" cy="292608"/>
+            <a:off x="1371600" y="2624328"/>
+            <a:ext cx="3108960" cy="292608"/>
           </a:xfrm>
           <a:prstGeom prst="rect">
             <a:avLst/>
@@ -5090,7 +5483,7 @@
           <a:ln/>
         </p:spPr>
         <p:txBody>
-          <a:bodyPr wrap="square" lIns="0" tIns="0" rIns="0" bIns="0" rtlCol="0" anchor="ctr"/>
+          <a:bodyPr wrap="square" lIns="0" tIns="0" rIns="0" bIns="0" rtlCol="0" anchor="t"/>
           <a:lstStyle/>
           <a:p>
             <a:pPr marL="0" indent="0">
@@ -5119,26 +5512,35 @@
         </p:nvSpPr>
         <p:spPr>
           <a:xfrm>
-            <a:off x="4663440" y="2103120"/>
-            <a:ext cx="594360" cy="594360"/>
-          </a:xfrm>
-          <a:prstGeom prst="ellipse">
-            <a:avLst/>
+            <a:off x="4663440" y="2240280"/>
+            <a:ext cx="731520" cy="731520"/>
+          </a:xfrm>
+          <a:prstGeom prst="roundRect">
+            <a:avLst>
+              <a:gd name="adj" fmla="val 22000"/>
+            </a:avLst>
           </a:prstGeom>
           <a:solidFill>
-            <a:srgbClr val="1446D6"/>
+            <a:srgbClr val="FFFFFF"/>
           </a:solidFill>
           <a:ln w="12700">
             <a:solidFill>
-              <a:srgbClr val="1446D6"/>
+              <a:srgbClr val="FFFFFF"/>
             </a:solidFill>
             <a:prstDash val="solid"/>
           </a:ln>
+          <a:effectLst>
+            <a:outerShdw blurRad="127000" dist="38100" dir="5400000" algn="bl" rotWithShape="0">
+              <a:srgbClr val="0F1B3D">
+                <a:alpha val="12000"/>
+              </a:srgbClr>
+            </a:outerShdw>
+          </a:effectLst>
         </p:spPr>
       </p:sp>
       <p:pic>
         <p:nvPicPr>
-          <p:cNvPr id="16" name="Image 3" descr="preencoded.png"/>
+          <p:cNvPr id="16" name="Image 3" descr="C:\Users\Admin\AppData\Local\Temp\claude\d--SmartTutor\5ff2c210-ed39-47c1-9187-8611ef6ccd50\scratchpad\deck\emoji\chart.png"/>
           <p:cNvPicPr>
             <a:picLocks noChangeAspect="1"/>
           </p:cNvPicPr>
@@ -5152,8 +5554,8 @@
         </p:blipFill>
         <p:spPr>
           <a:xfrm>
-            <a:off x="4812030" y="2251710"/>
-            <a:ext cx="297180" cy="297180"/>
+            <a:off x="4780483" y="2357323"/>
+            <a:ext cx="497434" cy="497434"/>
           </a:xfrm>
           <a:prstGeom prst="rect">
             <a:avLst/>
@@ -5168,8 +5570,8 @@
         </p:nvSpPr>
         <p:spPr>
           <a:xfrm>
-            <a:off x="5394960" y="2084832"/>
-            <a:ext cx="3291840" cy="329184"/>
+            <a:off x="5577840" y="2295144"/>
+            <a:ext cx="3108960" cy="329184"/>
           </a:xfrm>
           <a:prstGeom prst="rect">
             <a:avLst/>
@@ -5178,7 +5580,7 @@
           <a:ln/>
         </p:spPr>
         <p:txBody>
-          <a:bodyPr wrap="square" lIns="0" tIns="0" rIns="0" bIns="0" rtlCol="0" anchor="ctr"/>
+          <a:bodyPr wrap="square" lIns="0" tIns="0" rIns="0" bIns="0" rtlCol="0" anchor="t"/>
           <a:lstStyle/>
           <a:p>
             <a:pPr marL="0" indent="0">
@@ -5207,8 +5609,8 @@
         </p:nvSpPr>
         <p:spPr>
           <a:xfrm>
-            <a:off x="5394960" y="2414016"/>
-            <a:ext cx="3291840" cy="292608"/>
+            <a:off x="5577840" y="2624328"/>
+            <a:ext cx="3108960" cy="292608"/>
           </a:xfrm>
           <a:prstGeom prst="rect">
             <a:avLst/>
@@ -5217,7 +5619,7 @@
           <a:ln/>
         </p:spPr>
         <p:txBody>
-          <a:bodyPr wrap="square" lIns="0" tIns="0" rIns="0" bIns="0" rtlCol="0" anchor="ctr"/>
+          <a:bodyPr wrap="square" lIns="0" tIns="0" rIns="0" bIns="0" rtlCol="0" anchor="t"/>
           <a:lstStyle/>
           <a:p>
             <a:pPr marL="0" indent="0">
@@ -5240,14 +5642,41 @@
       </p:sp>
       <p:sp>
         <p:nvSpPr>
-          <p:cNvPr id="19" name="Text 13"/>
+          <p:cNvPr id="19" name="Shape 13"/>
+          <p:cNvSpPr/>
+          <p:nvPr/>
+        </p:nvSpPr>
+        <p:spPr>
+          <a:xfrm>
+            <a:off x="457200" y="3611880"/>
+            <a:ext cx="8229600" cy="868680"/>
+          </a:xfrm>
+          <a:prstGeom prst="roundRect">
+            <a:avLst>
+              <a:gd name="adj" fmla="val 12632"/>
+            </a:avLst>
+          </a:prstGeom>
+          <a:solidFill>
+            <a:srgbClr val="1B2A55"/>
+          </a:solidFill>
+          <a:ln w="12700">
+            <a:solidFill>
+              <a:srgbClr val="1B2A55"/>
+            </a:solidFill>
+            <a:prstDash val="solid"/>
+          </a:ln>
+        </p:spPr>
+      </p:sp>
+      <p:sp>
+        <p:nvSpPr>
+          <p:cNvPr id="21" name="Text 14"/>
           <p:cNvSpPr txBox="1"/>
           <p:nvPr/>
         </p:nvSpPr>
         <p:spPr>
           <a:xfrm>
-            <a:off x="457200" y="3337560"/>
-            <a:ext cx="8229600" cy="502920"/>
+            <a:off x="1417320" y="3611880"/>
+            <a:ext cx="7132320" cy="868680"/>
           </a:xfrm>
           <a:prstGeom prst="rect">
             <a:avLst/>
@@ -5263,7 +5692,7 @@
               <a:buNone/>
             </a:pPr>
             <a:r>
-              <a:rPr lang="en-US" sz="2400" b="1" dirty="0">
+              <a:rPr lang="en-US" sz="2200" b="1" dirty="0">
                 <a:solidFill>
                   <a:srgbClr val="FFC845"/>
                 </a:solidFill>
@@ -5273,20 +5702,53 @@
               </a:rPr>
               <a:t>SmartTutor: a training module for an HR platform</a:t>
             </a:r>
-            <a:endParaRPr lang="en-US" sz="2400" dirty="0"/>
-          </a:p>
-        </p:txBody>
-      </p:sp>
-      <p:sp>
-        <p:nvSpPr>
-          <p:cNvPr id="20" name="Text 14"/>
+            <a:endParaRPr lang="en-US" sz="2200" dirty="0"/>
+          </a:p>
+        </p:txBody>
+      </p:sp>
+    </p:spTree>
+  </p:cSld>
+  <p:clrMapOvr>
+    <a:masterClrMapping/>
+  </p:clrMapOvr>
+</p:sld>
+</file>
+
+<file path=ppt/slides/slide9.xml><?xml version="1.0" encoding="utf-8"?>
+<p:sld xmlns:a="http://schemas.openxmlformats.org/drawingml/2006/main" xmlns:r="http://schemas.openxmlformats.org/officeDocument/2006/relationships" xmlns:p="http://schemas.openxmlformats.org/presentationml/2006/main">
+  <p:cSld name="Slide 10">
+    <p:bg>
+      <p:bgPr>
+        <a:solidFill>
+          <a:srgbClr val="0F1B3D"/>
+        </a:solidFill>
+        <a:effectLst/>
+      </p:bgPr>
+    </p:bg>
+    <p:spTree>
+      <p:nvGrpSpPr>
+        <p:cNvPr id="1" name=""/>
+        <p:cNvGrpSpPr/>
+        <p:nvPr/>
+      </p:nvGrpSpPr>
+      <p:grpSpPr>
+        <a:xfrm>
+          <a:off x="0" y="0"/>
+          <a:ext cx="0" cy="0"/>
+          <a:chOff x="0" y="0"/>
+          <a:chExt cx="0" cy="0"/>
+        </a:xfrm>
+      </p:grpSpPr>
+      <p:sp>
+        <p:nvSpPr>
+          <p:cNvPr id="3" name="Text 0"/>
           <p:cNvSpPr txBox="1"/>
           <p:nvPr/>
         </p:nvSpPr>
         <p:spPr>
           <a:xfrm>
-            <a:off x="457200" y="3931920"/>
-            <a:ext cx="8229600" cy="457200"/>
+            <a:off x="457200" y="2103120"/>
+            <a:ext cx="8229600" cy="914400"/>
           </a:xfrm>
           <a:prstGeom prst="rect">
             <a:avLst/>
@@ -5298,11 +5760,11 @@
           <a:bodyPr wrap="square" lIns="0" tIns="0" rIns="0" bIns="0" rtlCol="0" anchor="ctr"/>
           <a:lstStyle/>
           <a:p>
-            <a:pPr marL="0" indent="0">
+            <a:pPr marL="0" indent="0" algn="ctr">
               <a:buNone/>
             </a:pPr>
             <a:r>
-              <a:rPr lang="en-US" sz="1800" dirty="0">
+              <a:rPr lang="en-US" sz="6000" b="1" dirty="0">
                 <a:solidFill>
                   <a:srgbClr val="FFFFFF"/>
                 </a:solidFill>
@@ -5310,9 +5772,87 @@
                 <a:ea typeface="Calibri" pitchFamily="34" charset="-122"/>
                 <a:cs typeface="Calibri" pitchFamily="34" charset="-120"/>
               </a:rPr>
-              <a:t>Thank you. Questions?</a:t>
-            </a:r>
-            <a:endParaRPr lang="en-US" sz="1800" dirty="0"/>
+              <a:t>Thank you</a:t>
+            </a:r>
+            <a:endParaRPr lang="en-US" sz="6000" dirty="0"/>
+          </a:p>
+        </p:txBody>
+      </p:sp>
+      <p:sp>
+        <p:nvSpPr>
+          <p:cNvPr id="5" name="Text 2"/>
+          <p:cNvSpPr txBox="1"/>
+          <p:nvPr/>
+        </p:nvSpPr>
+        <p:spPr>
+          <a:xfrm>
+            <a:off x="457200" y="3749040"/>
+            <a:ext cx="8229600" cy="731520"/>
+          </a:xfrm>
+          <a:prstGeom prst="rect">
+            <a:avLst/>
+          </a:prstGeom>
+          <a:noFill/>
+          <a:ln/>
+        </p:spPr>
+        <p:txBody>
+          <a:bodyPr wrap="square" lIns="0" tIns="0" rIns="0" bIns="0" rtlCol="0" anchor="t"/>
+          <a:lstStyle/>
+          <a:p>
+            <a:pPr marL="0" indent="0" algn="ctr">
+              <a:buNone/>
+            </a:pPr>
+            <a:r>
+              <a:rPr lang="en-US" sz="1300" dirty="0">
+                <a:solidFill>
+                  <a:srgbClr val="9AA6C8"/>
+                </a:solidFill>
+                <a:latin typeface="Calibri" pitchFamily="34" charset="0"/>
+                <a:ea typeface="Calibri" pitchFamily="34" charset="-122"/>
+                <a:cs typeface="Calibri" pitchFamily="34" charset="-120"/>
+              </a:rPr>
+              <a:t>Source code  </a:t>
+            </a:r>
+            <a:r>
+              <a:rPr lang="en-US" sz="1300" dirty="0">
+                <a:solidFill>
+                  <a:srgbClr val="FFFFFF"/>
+                </a:solidFill>
+                <a:latin typeface="Calibri" pitchFamily="34" charset="0"/>
+                <a:ea typeface="Calibri" pitchFamily="34" charset="-122"/>
+                <a:cs typeface="Calibri" pitchFamily="34" charset="-120"/>
+              </a:rPr>
+              <a:t>github.com/phucdhcoder19/smarttutor</a:t>
+            </a:r>
+            <a:endParaRPr lang="en-US" sz="1300" dirty="0"/>
+          </a:p>
+          <a:p>
+            <a:pPr marL="0" indent="0" algn="ctr">
+              <a:buNone/>
+            </a:pPr>
+            <a:r>
+              <a:rPr lang="en-US" sz="1300" dirty="0">
+                <a:solidFill>
+                  <a:srgbClr val="9AA6C8"/>
+                </a:solidFill>
+                <a:latin typeface="Calibri" pitchFamily="34" charset="0"/>
+                <a:ea typeface="Calibri" pitchFamily="34" charset="-122"/>
+                <a:cs typeface="Calibri" pitchFamily="34" charset="-120"/>
+              </a:rPr>
+              <a:t>APK and demo video  </a:t>
+            </a:r>
+            <a:r>
+              <a:rPr lang="en-US" sz="1300" dirty="0">
+                <a:solidFill>
+                  <a:srgbClr val="FFFFFF"/>
+                </a:solidFill>
+                <a:latin typeface="Calibri" pitchFamily="34" charset="0"/>
+                <a:ea typeface="Calibri" pitchFamily="34" charset="-122"/>
+                <a:cs typeface="Calibri" pitchFamily="34" charset="-120"/>
+              </a:rPr>
+              <a:t>linked in the README</a:t>
+            </a:r>
+            <a:endParaRPr lang="en-US" sz="1300" dirty="0"/>
           </a:p>
         </p:txBody>
       </p:sp>

</xml_diff>